<commit_message>
Added ppt generator agent from database
</commit_message>
<xml_diff>
--- a/Backend/Presentation.pptx
+++ b/Backend/Presentation.pptx
@@ -11,8 +11,6 @@
     <p:sldId id="259" r:id="rId9"/>
     <p:sldId id="260" r:id="rId10"/>
     <p:sldId id="261" r:id="rId11"/>
-    <p:sldId id="262" r:id="rId12"/>
-    <p:sldId id="263" r:id="rId13"/>
   </p:sldIdLst>
   <p:sldSz cx="9144000" cy="6858000" type="screen4x3"/>
   <p:notesSz cx="6858000" cy="9144000"/>
@@ -2994,7 +2992,7 @@
               <a:defRPr sz="5000" b="1"/>
             </a:pPr>
             <a:r>
-              <a:t>Dataset Overview</a:t>
+              <a:t>AI Trends in 2024: A Comprehensive Overview</a:t>
             </a:r>
           </a:p>
         </p:txBody>
@@ -3121,7 +3119,7 @@
                         </a:defRPr>
                       </a:pPr>
                       <a:r>
-                        <a:t>Dataset Overview</a:t>
+                        <a:t>AI Trends in 2024: A Comprehensive Overview</a:t>
                       </a:r>
                     </a:p>
                   </a:txBody>
@@ -3253,7 +3251,7 @@
                         </a:defRPr>
                       </a:pPr>
                       <a:r>
-                        <a:t>vdfv</a:t>
+                        <a:t>rghbr</a:t>
                       </a:r>
                     </a:p>
                   </a:txBody>
@@ -3297,7 +3295,7 @@
                         </a:defRPr>
                       </a:pPr>
                       <a:r>
-                        <a:t>vbfhd@bfhrb.vnjdfv</a:t>
+                        <a:t>brghbfhrbh@hbh.ej</a:t>
                       </a:r>
                     </a:p>
                   </a:txBody>
@@ -3341,7 +3339,7 @@
                         </a:defRPr>
                       </a:pPr>
                       <a:r>
-                        <a:t>vfbvh b</a:t>
+                        <a:t>fbhrb</a:t>
                       </a:r>
                     </a:p>
                   </a:txBody>
@@ -3385,7 +3383,7 @@
                         </a:defRPr>
                       </a:pPr>
                       <a:r>
-                        <a:t>fvbhfd</a:t>
+                        <a:t>bhb</a:t>
                       </a:r>
                     </a:p>
                   </a:txBody>
@@ -3529,2432 +3527,72 @@
           <a:lstStyle/>
           <a:p>
             <a:r>
-              <a:t>Customer Demographics</a:t>
-            </a:r>
-          </a:p>
-        </p:txBody>
-      </p:sp>
-      <p:graphicFrame>
-        <p:nvGraphicFramePr>
-          <p:cNvPr id="3" name="Table 2"/>
-          <p:cNvGraphicFramePr>
-            <a:graphicFrameLocks noGrp="1"/>
-          </p:cNvGraphicFramePr>
-          <p:nvPr/>
-        </p:nvGraphicFramePr>
-        <p:xfrm>
-          <a:off x="1097280" y="1828800"/>
-          <a:ext cx="7315200" cy="2926080"/>
-        </p:xfrm>
-        <a:graphic>
-          <a:graphicData uri="http://schemas.openxmlformats.org/drawingml/2006/table">
-            <a:tbl>
-              <a:tblPr firstRow="1" bandRow="1">
-                <a:tableStyleId>{5C22544A-7EE6-4342-B048-85BDC9FD1C3A}</a:tableStyleId>
-              </a:tblPr>
-              <a:tblGrid>
-                <a:gridCol w="812800"/>
-                <a:gridCol w="812800"/>
-                <a:gridCol w="812800"/>
-                <a:gridCol w="812800"/>
-                <a:gridCol w="812800"/>
-                <a:gridCol w="812800"/>
-                <a:gridCol w="812800"/>
-                <a:gridCol w="812800"/>
-                <a:gridCol w="812800"/>
-              </a:tblGrid>
-              <a:tr h="731520">
-                <a:tc>
-                  <a:txBody>
-                    <a:bodyPr wrap="square"/>
-                    <a:lstStyle/>
-                    <a:p>
-                      <a:pPr algn="ctr">
-                        <a:defRPr b="1" sz="1800">
-                          <a:solidFill>
-                            <a:srgbClr val="FFFFFF"/>
-                          </a:solidFill>
-                        </a:defRPr>
-                      </a:pPr>
-                      <a:r>
-                        <a:t>Customer ID</a:t>
-                      </a:r>
-                    </a:p>
-                  </a:txBody>
-                  <a:tcPr marL="18288" marR="18288">
-                    <a:solidFill>
-                      <a:srgbClr val="003366"/>
-                    </a:solidFill>
-                  </a:tcPr>
-                </a:tc>
-                <a:tc>
-                  <a:txBody>
-                    <a:bodyPr wrap="square"/>
-                    <a:lstStyle/>
-                    <a:p>
-                      <a:pPr algn="ctr">
-                        <a:defRPr b="1" sz="1800">
-                          <a:solidFill>
-                            <a:srgbClr val="FFFFFF"/>
-                          </a:solidFill>
-                        </a:defRPr>
-                      </a:pPr>
-                      <a:r>
-                        <a:t>Name</a:t>
-                      </a:r>
-                    </a:p>
-                  </a:txBody>
-                  <a:tcPr marL="18288" marR="18288">
-                    <a:solidFill>
-                      <a:srgbClr val="003366"/>
-                    </a:solidFill>
-                  </a:tcPr>
-                </a:tc>
-                <a:tc>
-                  <a:txBody>
-                    <a:bodyPr wrap="square"/>
-                    <a:lstStyle/>
-                    <a:p>
-                      <a:pPr algn="ctr">
-                        <a:defRPr b="1" sz="1800">
-                          <a:solidFill>
-                            <a:srgbClr val="FFFFFF"/>
-                          </a:solidFill>
-                        </a:defRPr>
-                      </a:pPr>
-                      <a:r>
-                        <a:t>Gender</a:t>
-                      </a:r>
-                    </a:p>
-                  </a:txBody>
-                  <a:tcPr marL="18288" marR="18288">
-                    <a:solidFill>
-                      <a:srgbClr val="003366"/>
-                    </a:solidFill>
-                  </a:tcPr>
-                </a:tc>
-                <a:tc>
-                  <a:txBody>
-                    <a:bodyPr wrap="square"/>
-                    <a:lstStyle/>
-                    <a:p>
-                      <a:pPr algn="ctr">
-                        <a:defRPr b="1" sz="1800">
-                          <a:solidFill>
-                            <a:srgbClr val="FFFFFF"/>
-                          </a:solidFill>
-                        </a:defRPr>
-                      </a:pPr>
-                      <a:r>
-                        <a:t>Age</a:t>
-                      </a:r>
-                    </a:p>
-                  </a:txBody>
-                  <a:tcPr marL="18288" marR="18288">
-                    <a:solidFill>
-                      <a:srgbClr val="003366"/>
-                    </a:solidFill>
-                  </a:tcPr>
-                </a:tc>
-                <a:tc>
-                  <a:txBody>
-                    <a:bodyPr wrap="square"/>
-                    <a:lstStyle/>
-                    <a:p>
-                      <a:pPr algn="ctr">
-                        <a:defRPr b="1" sz="1800">
-                          <a:solidFill>
-                            <a:srgbClr val="FFFFFF"/>
-                          </a:solidFill>
-                        </a:defRPr>
-                      </a:pPr>
-                      <a:r>
-                        <a:t>City</a:t>
-                      </a:r>
-                    </a:p>
-                  </a:txBody>
-                  <a:tcPr marL="18288" marR="18288">
-                    <a:solidFill>
-                      <a:srgbClr val="003366"/>
-                    </a:solidFill>
-                  </a:tcPr>
-                </a:tc>
-                <a:tc>
-                  <a:txBody>
-                    <a:bodyPr wrap="square"/>
-                    <a:lstStyle/>
-                    <a:p>
-                      <a:pPr algn="ctr">
-                        <a:defRPr b="1" sz="1800">
-                          <a:solidFill>
-                            <a:srgbClr val="FFFFFF"/>
-                          </a:solidFill>
-                        </a:defRPr>
-                      </a:pPr>
-                      <a:r>
-                        <a:t>State</a:t>
-                      </a:r>
-                    </a:p>
-                  </a:txBody>
-                  <a:tcPr marL="18288" marR="18288">
-                    <a:solidFill>
-                      <a:srgbClr val="003366"/>
-                    </a:solidFill>
-                  </a:tcPr>
-                </a:tc>
-                <a:tc>
-                  <a:txBody>
-                    <a:bodyPr wrap="square"/>
-                    <a:lstStyle/>
-                    <a:p>
-                      <a:pPr algn="ctr">
-                        <a:defRPr b="1" sz="1800">
-                          <a:solidFill>
-                            <a:srgbClr val="FFFFFF"/>
-                          </a:solidFill>
-                        </a:defRPr>
-                      </a:pPr>
-                      <a:r>
-                        <a:t>Country</a:t>
-                      </a:r>
-                    </a:p>
-                  </a:txBody>
-                  <a:tcPr marL="18288" marR="18288">
-                    <a:solidFill>
-                      <a:srgbClr val="003366"/>
-                    </a:solidFill>
-                  </a:tcPr>
-                </a:tc>
-                <a:tc>
-                  <a:txBody>
-                    <a:bodyPr wrap="square"/>
-                    <a:lstStyle/>
-                    <a:p>
-                      <a:pPr algn="ctr">
-                        <a:defRPr b="1" sz="1800">
-                          <a:solidFill>
-                            <a:srgbClr val="FFFFFF"/>
-                          </a:solidFill>
-                        </a:defRPr>
-                      </a:pPr>
-                      <a:r>
-                        <a:t>Signup Date</a:t>
-                      </a:r>
-                    </a:p>
-                  </a:txBody>
-                  <a:tcPr marL="18288" marR="18288">
-                    <a:solidFill>
-                      <a:srgbClr val="003366"/>
-                    </a:solidFill>
-                  </a:tcPr>
-                </a:tc>
-                <a:tc>
-                  <a:txBody>
-                    <a:bodyPr wrap="square"/>
-                    <a:lstStyle/>
-                    <a:p>
-                      <a:pPr algn="ctr">
-                        <a:defRPr b="1" sz="1800">
-                          <a:solidFill>
-                            <a:srgbClr val="FFFFFF"/>
-                          </a:solidFill>
-                        </a:defRPr>
-                      </a:pPr>
-                      <a:r>
-                        <a:t>Loyalty Tier</a:t>
-                      </a:r>
-                    </a:p>
-                  </a:txBody>
-                  <a:tcPr marL="18288" marR="18288">
-                    <a:solidFill>
-                      <a:srgbClr val="003366"/>
-                    </a:solidFill>
-                  </a:tcPr>
-                </a:tc>
-              </a:tr>
-              <a:tr h="731520">
-                <a:tc>
-                  <a:txBody>
-                    <a:bodyPr wrap="square"/>
-                    <a:lstStyle/>
-                    <a:p>
-                      <a:pPr algn="l">
-                        <a:defRPr sz="1400"/>
-                      </a:pPr>
-                      <a:r>
-                        <a:t>CUST001</a:t>
-                      </a:r>
-                    </a:p>
-                  </a:txBody>
-                  <a:tcPr marL="18288" marR="18288"/>
-                </a:tc>
-                <a:tc>
-                  <a:txBody>
-                    <a:bodyPr wrap="square"/>
-                    <a:lstStyle/>
-                    <a:p>
-                      <a:pPr algn="l">
-                        <a:defRPr sz="1400"/>
-                      </a:pPr>
-                      <a:r>
-                        <a:t>Hetanshi Patel</a:t>
-                      </a:r>
-                    </a:p>
-                  </a:txBody>
-                  <a:tcPr marL="18288" marR="18288"/>
-                </a:tc>
-                <a:tc>
-                  <a:txBody>
-                    <a:bodyPr wrap="square"/>
-                    <a:lstStyle/>
-                    <a:p>
-                      <a:pPr algn="l">
-                        <a:defRPr sz="1400"/>
-                      </a:pPr>
-                      <a:r>
-                        <a:t>Female</a:t>
-                      </a:r>
-                    </a:p>
-                  </a:txBody>
-                  <a:tcPr marL="18288" marR="18288"/>
-                </a:tc>
-                <a:tc>
-                  <a:txBody>
-                    <a:bodyPr wrap="square"/>
-                    <a:lstStyle/>
-                    <a:p>
-                      <a:pPr algn="l">
-                        <a:defRPr sz="1400"/>
-                      </a:pPr>
-                      <a:r>
-                        <a:t>23</a:t>
-                      </a:r>
-                    </a:p>
-                  </a:txBody>
-                  <a:tcPr marL="18288" marR="18288"/>
-                </a:tc>
-                <a:tc>
-                  <a:txBody>
-                    <a:bodyPr wrap="square"/>
-                    <a:lstStyle/>
-                    <a:p>
-                      <a:pPr algn="l">
-                        <a:defRPr sz="1400"/>
-                      </a:pPr>
-                      <a:r>
-                        <a:t>Ahmedabad</a:t>
-                      </a:r>
-                    </a:p>
-                  </a:txBody>
-                  <a:tcPr marL="18288" marR="18288"/>
-                </a:tc>
-                <a:tc>
-                  <a:txBody>
-                    <a:bodyPr wrap="square"/>
-                    <a:lstStyle/>
-                    <a:p>
-                      <a:pPr algn="l">
-                        <a:defRPr sz="1400"/>
-                      </a:pPr>
-                      <a:r>
-                        <a:t>Gujarat</a:t>
-                      </a:r>
-                    </a:p>
-                  </a:txBody>
-                  <a:tcPr marL="18288" marR="18288"/>
-                </a:tc>
-                <a:tc>
-                  <a:txBody>
-                    <a:bodyPr wrap="square"/>
-                    <a:lstStyle/>
-                    <a:p>
-                      <a:pPr algn="l">
-                        <a:defRPr sz="1400"/>
-                      </a:pPr>
-                      <a:r>
-                        <a:t>India</a:t>
-                      </a:r>
-                    </a:p>
-                  </a:txBody>
-                  <a:tcPr marL="18288" marR="18288"/>
-                </a:tc>
-                <a:tc>
-                  <a:txBody>
-                    <a:bodyPr wrap="square"/>
-                    <a:lstStyle/>
-                    <a:p>
-                      <a:pPr algn="l">
-                        <a:defRPr sz="1400"/>
-                      </a:pPr>
-                      <a:r>
-                        <a:t>2024-01-15</a:t>
-                      </a:r>
-                    </a:p>
-                  </a:txBody>
-                  <a:tcPr marL="18288" marR="18288"/>
-                </a:tc>
-                <a:tc>
-                  <a:txBody>
-                    <a:bodyPr wrap="square"/>
-                    <a:lstStyle/>
-                    <a:p>
-                      <a:pPr algn="l">
-                        <a:defRPr sz="1400"/>
-                      </a:pPr>
-                      <a:r>
-                        <a:t>Gold</a:t>
-                      </a:r>
-                    </a:p>
-                  </a:txBody>
-                  <a:tcPr marL="18288" marR="18288"/>
-                </a:tc>
-              </a:tr>
-              <a:tr h="731520">
-                <a:tc>
-                  <a:txBody>
-                    <a:bodyPr wrap="square"/>
-                    <a:lstStyle/>
-                    <a:p>
-                      <a:pPr algn="l">
-                        <a:defRPr sz="1400"/>
-                      </a:pPr>
-                      <a:r>
-                        <a:t>CUST002</a:t>
-                      </a:r>
-                    </a:p>
-                  </a:txBody>
-                  <a:tcPr marL="18288" marR="18288"/>
-                </a:tc>
-                <a:tc>
-                  <a:txBody>
-                    <a:bodyPr wrap="square"/>
-                    <a:lstStyle/>
-                    <a:p>
-                      <a:pPr algn="l">
-                        <a:defRPr sz="1400"/>
-                      </a:pPr>
-                      <a:r>
-                        <a:t>Rahul Mehta</a:t>
-                      </a:r>
-                    </a:p>
-                  </a:txBody>
-                  <a:tcPr marL="18288" marR="18288"/>
-                </a:tc>
-                <a:tc>
-                  <a:txBody>
-                    <a:bodyPr wrap="square"/>
-                    <a:lstStyle/>
-                    <a:p>
-                      <a:pPr algn="l">
-                        <a:defRPr sz="1400"/>
-                      </a:pPr>
-                      <a:r>
-                        <a:t>Male</a:t>
-                      </a:r>
-                    </a:p>
-                  </a:txBody>
-                  <a:tcPr marL="18288" marR="18288"/>
-                </a:tc>
-                <a:tc>
-                  <a:txBody>
-                    <a:bodyPr wrap="square"/>
-                    <a:lstStyle/>
-                    <a:p>
-                      <a:pPr algn="l">
-                        <a:defRPr sz="1400"/>
-                      </a:pPr>
-                      <a:r>
-                        <a:t>29</a:t>
-                      </a:r>
-                    </a:p>
-                  </a:txBody>
-                  <a:tcPr marL="18288" marR="18288"/>
-                </a:tc>
-                <a:tc>
-                  <a:txBody>
-                    <a:bodyPr wrap="square"/>
-                    <a:lstStyle/>
-                    <a:p>
-                      <a:pPr algn="l">
-                        <a:defRPr sz="1400"/>
-                      </a:pPr>
-                      <a:r>
-                        <a:t>Mumbai</a:t>
-                      </a:r>
-                    </a:p>
-                  </a:txBody>
-                  <a:tcPr marL="18288" marR="18288"/>
-                </a:tc>
-                <a:tc>
-                  <a:txBody>
-                    <a:bodyPr wrap="square"/>
-                    <a:lstStyle/>
-                    <a:p>
-                      <a:pPr algn="l">
-                        <a:defRPr sz="1400"/>
-                      </a:pPr>
-                      <a:r>
-                        <a:t>Maharashtra</a:t>
-                      </a:r>
-                    </a:p>
-                  </a:txBody>
-                  <a:tcPr marL="18288" marR="18288"/>
-                </a:tc>
-                <a:tc>
-                  <a:txBody>
-                    <a:bodyPr wrap="square"/>
-                    <a:lstStyle/>
-                    <a:p>
-                      <a:pPr algn="l">
-                        <a:defRPr sz="1400"/>
-                      </a:pPr>
-                      <a:r>
-                        <a:t>India</a:t>
-                      </a:r>
-                    </a:p>
-                  </a:txBody>
-                  <a:tcPr marL="18288" marR="18288"/>
-                </a:tc>
-                <a:tc>
-                  <a:txBody>
-                    <a:bodyPr wrap="square"/>
-                    <a:lstStyle/>
-                    <a:p>
-                      <a:pPr algn="l">
-                        <a:defRPr sz="1400"/>
-                      </a:pPr>
-                      <a:r>
-                        <a:t>2023-11-20</a:t>
-                      </a:r>
-                    </a:p>
-                  </a:txBody>
-                  <a:tcPr marL="18288" marR="18288"/>
-                </a:tc>
-                <a:tc>
-                  <a:txBody>
-                    <a:bodyPr wrap="square"/>
-                    <a:lstStyle/>
-                    <a:p>
-                      <a:pPr algn="l">
-                        <a:defRPr sz="1400"/>
-                      </a:pPr>
-                      <a:r>
-                        <a:t>Silver</a:t>
-                      </a:r>
-                    </a:p>
-                  </a:txBody>
-                  <a:tcPr marL="18288" marR="18288"/>
-                </a:tc>
-              </a:tr>
-              <a:tr h="731520">
-                <a:tc>
-                  <a:txBody>
-                    <a:bodyPr wrap="square"/>
-                    <a:lstStyle/>
-                    <a:p>
-                      <a:pPr algn="l">
-                        <a:defRPr sz="1400"/>
-                      </a:pPr>
-                      <a:r>
-                        <a:t>CUST003</a:t>
-                      </a:r>
-                    </a:p>
-                  </a:txBody>
-                  <a:tcPr marL="18288" marR="18288"/>
-                </a:tc>
-                <a:tc>
-                  <a:txBody>
-                    <a:bodyPr wrap="square"/>
-                    <a:lstStyle/>
-                    <a:p>
-                      <a:pPr algn="l">
-                        <a:defRPr sz="1400"/>
-                      </a:pPr>
-                      <a:r>
-                        <a:t>Ananya Singh</a:t>
-                      </a:r>
-                    </a:p>
-                  </a:txBody>
-                  <a:tcPr marL="18288" marR="18288"/>
-                </a:tc>
-                <a:tc>
-                  <a:txBody>
-                    <a:bodyPr wrap="square"/>
-                    <a:lstStyle/>
-                    <a:p>
-                      <a:pPr algn="l">
-                        <a:defRPr sz="1400"/>
-                      </a:pPr>
-                      <a:r>
-                        <a:t>Female</a:t>
-                      </a:r>
-                    </a:p>
-                  </a:txBody>
-                  <a:tcPr marL="18288" marR="18288"/>
-                </a:tc>
-                <a:tc>
-                  <a:txBody>
-                    <a:bodyPr wrap="square"/>
-                    <a:lstStyle/>
-                    <a:p>
-                      <a:pPr algn="l">
-                        <a:defRPr sz="1400"/>
-                      </a:pPr>
-                      <a:r>
-                        <a:t>34</a:t>
-                      </a:r>
-                    </a:p>
-                  </a:txBody>
-                  <a:tcPr marL="18288" marR="18288"/>
-                </a:tc>
-                <a:tc>
-                  <a:txBody>
-                    <a:bodyPr wrap="square"/>
-                    <a:lstStyle/>
-                    <a:p>
-                      <a:pPr algn="l">
-                        <a:defRPr sz="1400"/>
-                      </a:pPr>
-                      <a:r>
-                        <a:t>Delhi</a:t>
-                      </a:r>
-                    </a:p>
-                  </a:txBody>
-                  <a:tcPr marL="18288" marR="18288"/>
-                </a:tc>
-                <a:tc>
-                  <a:txBody>
-                    <a:bodyPr wrap="square"/>
-                    <a:lstStyle/>
-                    <a:p>
-                      <a:pPr algn="l">
-                        <a:defRPr sz="1400"/>
-                      </a:pPr>
-                      <a:r>
-                        <a:t>Delhi</a:t>
-                      </a:r>
-                    </a:p>
-                  </a:txBody>
-                  <a:tcPr marL="18288" marR="18288"/>
-                </a:tc>
-                <a:tc>
-                  <a:txBody>
-                    <a:bodyPr wrap="square"/>
-                    <a:lstStyle/>
-                    <a:p>
-                      <a:pPr algn="l">
-                        <a:defRPr sz="1400"/>
-                      </a:pPr>
-                      <a:r>
-                        <a:t>India</a:t>
-                      </a:r>
-                    </a:p>
-                  </a:txBody>
-                  <a:tcPr marL="18288" marR="18288"/>
-                </a:tc>
-                <a:tc>
-                  <a:txBody>
-                    <a:bodyPr wrap="square"/>
-                    <a:lstStyle/>
-                    <a:p>
-                      <a:pPr algn="l">
-                        <a:defRPr sz="1400"/>
-                      </a:pPr>
-                      <a:r>
-                        <a:t>2022-08-10</a:t>
-                      </a:r>
-                    </a:p>
-                  </a:txBody>
-                  <a:tcPr marL="18288" marR="18288"/>
-                </a:tc>
-                <a:tc>
-                  <a:txBody>
-                    <a:bodyPr wrap="square"/>
-                    <a:lstStyle/>
-                    <a:p>
-                      <a:pPr algn="l">
-                        <a:defRPr sz="1400"/>
-                      </a:pPr>
-                      <a:r>
-                        <a:t>Platinum</a:t>
-                      </a:r>
-                    </a:p>
-                  </a:txBody>
-                  <a:tcPr marL="18288" marR="18288"/>
-                </a:tc>
-              </a:tr>
-            </a:tbl>
-          </a:graphicData>
-        </a:graphic>
-      </p:graphicFrame>
-      <p:sp>
-        <p:nvSpPr>
-          <p:cNvPr id="4" name="TextBox 3"/>
-          <p:cNvSpPr txBox="1"/>
-          <p:nvPr/>
-        </p:nvSpPr>
-        <p:spPr>
-          <a:xfrm>
-            <a:off x="914400" y="5943600"/>
-            <a:ext cx="7315200" cy="1097280"/>
-          </a:xfrm>
-          <a:prstGeom prst="rect">
-            <a:avLst/>
-          </a:prstGeom>
-          <a:noFill/>
-        </p:spPr>
-        <p:txBody>
-          <a:bodyPr wrap="square">
-            <a:spAutoFit/>
-          </a:bodyPr>
-          <a:lstStyle/>
-          <a:p>
-            <a:pPr algn="l">
-              <a:defRPr sz="1100"/>
-            </a:pPr>
-            <a:r>
-              <a:t>The dataset includes customer demographics, showing a diverse range of ages, genders, and locations. The loyalty tiers indicate varying levels of customer engagement. Understanding these demographics can help tailor marketing strategies and improve customer retention.</a:t>
-            </a:r>
-          </a:p>
-        </p:txBody>
-      </p:sp>
-      <p:pic>
-        <p:nvPicPr>
-          <p:cNvPr id="5" name="Picture 4" descr="logo.png"/>
-          <p:cNvPicPr>
-            <a:picLocks noChangeAspect="1"/>
-          </p:cNvPicPr>
-          <p:nvPr/>
-        </p:nvPicPr>
-        <p:blipFill>
-          <a:blip r:embed="rId2"/>
-          <a:stretch>
-            <a:fillRect/>
-          </a:stretch>
-        </p:blipFill>
-        <p:spPr>
-          <a:xfrm>
-            <a:off x="182880" y="182880"/>
-            <a:ext cx="1865376" cy="286335"/>
-          </a:xfrm>
-          <a:prstGeom prst="rect">
-            <a:avLst/>
-          </a:prstGeom>
-        </p:spPr>
-      </p:pic>
-      <p:sp>
-        <p:nvSpPr>
-          <p:cNvPr id="6" name="TextBox 5"/>
-          <p:cNvSpPr txBox="1"/>
-          <p:nvPr/>
-        </p:nvSpPr>
-        <p:spPr>
-          <a:xfrm>
-            <a:off x="8229600" y="6492240"/>
-            <a:ext cx="731520" cy="365760"/>
-          </a:xfrm>
-          <a:prstGeom prst="rect">
-            <a:avLst/>
-          </a:prstGeom>
-          <a:noFill/>
-        </p:spPr>
-        <p:txBody>
-          <a:bodyPr wrap="none">
-            <a:spAutoFit/>
-          </a:bodyPr>
-          <a:lstStyle/>
-          <a:p>
-            <a:pPr algn="r">
+              <a:t>McKinsey Technology Trends Outlook: 2024</a:t>
+            </a:r>
+          </a:p>
+        </p:txBody>
+      </p:sp>
+      <p:sp>
+        <p:nvSpPr>
+          <p:cNvPr id="3" name="Content Placeholder 2"/>
+          <p:cNvSpPr>
+            <a:spLocks noGrp="1"/>
+          </p:cNvSpPr>
+          <p:nvPr>
+            <p:ph idx="1"/>
+          </p:nvPr>
+        </p:nvSpPr>
+        <p:spPr/>
+        <p:txBody>
+          <a:bodyPr/>
+          <a:lstStyle/>
+          <a:p/>
+          <a:p>
+            <a:pPr>
+              <a:spcAft>
+                <a:spcPts val="1200"/>
+              </a:spcAft>
               <a:defRPr sz="1800"/>
             </a:pPr>
             <a:r>
-              <a:t>3</a:t>
-            </a:r>
-          </a:p>
-        </p:txBody>
-      </p:sp>
-    </p:spTree>
-  </p:cSld>
-  <p:clrMapOvr>
-    <a:masterClrMapping/>
-  </p:clrMapOvr>
-</p:sld>
-</file>
-
-<file path=ppt/slides/slide4.xml><?xml version="1.0" encoding="utf-8"?>
-<p:sld xmlns:a="http://schemas.openxmlformats.org/drawingml/2006/main" xmlns:p="http://schemas.openxmlformats.org/presentationml/2006/main" xmlns:r="http://schemas.openxmlformats.org/officeDocument/2006/relationships">
-  <p:cSld>
-    <p:spTree>
-      <p:nvGrpSpPr>
-        <p:cNvPr id="1" name=""/>
-        <p:cNvGrpSpPr/>
-        <p:nvPr/>
-      </p:nvGrpSpPr>
-      <p:grpSpPr/>
-      <p:sp>
-        <p:nvSpPr>
-          <p:cNvPr id="2" name="Title 1"/>
-          <p:cNvSpPr>
-            <a:spLocks noGrp="1"/>
-          </p:cNvSpPr>
-          <p:nvPr>
-            <p:ph type="title"/>
-          </p:nvPr>
-        </p:nvSpPr>
-        <p:spPr/>
-        <p:txBody>
-          <a:bodyPr/>
-          <a:lstStyle/>
-          <a:p>
-            <a:r>
-              <a:t>Product Details</a:t>
-            </a:r>
-          </a:p>
-        </p:txBody>
-      </p:sp>
-      <p:graphicFrame>
-        <p:nvGraphicFramePr>
-          <p:cNvPr id="3" name="Table 2"/>
-          <p:cNvGraphicFramePr>
-            <a:graphicFrameLocks noGrp="1"/>
-          </p:cNvGraphicFramePr>
-          <p:nvPr/>
-        </p:nvGraphicFramePr>
-        <p:xfrm>
-          <a:off x="1097280" y="1828800"/>
-          <a:ext cx="7315200" cy="2926080"/>
-        </p:xfrm>
-        <a:graphic>
-          <a:graphicData uri="http://schemas.openxmlformats.org/drawingml/2006/table">
-            <a:tbl>
-              <a:tblPr firstRow="1" bandRow="1">
-                <a:tableStyleId>{5C22544A-7EE6-4342-B048-85BDC9FD1C3A}</a:tableStyleId>
-              </a:tblPr>
-              <a:tblGrid>
-                <a:gridCol w="1219200"/>
-                <a:gridCol w="1219200"/>
-                <a:gridCol w="1219200"/>
-                <a:gridCol w="1219200"/>
-                <a:gridCol w="1219200"/>
-                <a:gridCol w="1219200"/>
-              </a:tblGrid>
-              <a:tr h="731520">
-                <a:tc>
-                  <a:txBody>
-                    <a:bodyPr wrap="square"/>
-                    <a:lstStyle/>
-                    <a:p>
-                      <a:pPr algn="ctr">
-                        <a:defRPr b="1" sz="1800">
-                          <a:solidFill>
-                            <a:srgbClr val="FFFFFF"/>
-                          </a:solidFill>
-                        </a:defRPr>
-                      </a:pPr>
-                      <a:r>
-                        <a:t>Product ID</a:t>
-                      </a:r>
-                    </a:p>
-                  </a:txBody>
-                  <a:tcPr marL="18288" marR="18288">
-                    <a:solidFill>
-                      <a:srgbClr val="003366"/>
-                    </a:solidFill>
-                  </a:tcPr>
-                </a:tc>
-                <a:tc>
-                  <a:txBody>
-                    <a:bodyPr wrap="square"/>
-                    <a:lstStyle/>
-                    <a:p>
-                      <a:pPr algn="ctr">
-                        <a:defRPr b="1" sz="1800">
-                          <a:solidFill>
-                            <a:srgbClr val="FFFFFF"/>
-                          </a:solidFill>
-                        </a:defRPr>
-                      </a:pPr>
-                      <a:r>
-                        <a:t>Product Name</a:t>
-                      </a:r>
-                    </a:p>
-                  </a:txBody>
-                  <a:tcPr marL="18288" marR="18288">
-                    <a:solidFill>
-                      <a:srgbClr val="003366"/>
-                    </a:solidFill>
-                  </a:tcPr>
-                </a:tc>
-                <a:tc>
-                  <a:txBody>
-                    <a:bodyPr wrap="square"/>
-                    <a:lstStyle/>
-                    <a:p>
-                      <a:pPr algn="ctr">
-                        <a:defRPr b="1" sz="1800">
-                          <a:solidFill>
-                            <a:srgbClr val="FFFFFF"/>
-                          </a:solidFill>
-                        </a:defRPr>
-                      </a:pPr>
-                      <a:r>
-                        <a:t>Category</a:t>
-                      </a:r>
-                    </a:p>
-                  </a:txBody>
-                  <a:tcPr marL="18288" marR="18288">
-                    <a:solidFill>
-                      <a:srgbClr val="003366"/>
-                    </a:solidFill>
-                  </a:tcPr>
-                </a:tc>
-                <a:tc>
-                  <a:txBody>
-                    <a:bodyPr wrap="square"/>
-                    <a:lstStyle/>
-                    <a:p>
-                      <a:pPr algn="ctr">
-                        <a:defRPr b="1" sz="1800">
-                          <a:solidFill>
-                            <a:srgbClr val="FFFFFF"/>
-                          </a:solidFill>
-                        </a:defRPr>
-                      </a:pPr>
-                      <a:r>
-                        <a:t>Price (INR)</a:t>
-                      </a:r>
-                    </a:p>
-                  </a:txBody>
-                  <a:tcPr marL="18288" marR="18288">
-                    <a:solidFill>
-                      <a:srgbClr val="003366"/>
-                    </a:solidFill>
-                  </a:tcPr>
-                </a:tc>
-                <a:tc>
-                  <a:txBody>
-                    <a:bodyPr wrap="square"/>
-                    <a:lstStyle/>
-                    <a:p>
-                      <a:pPr algn="ctr">
-                        <a:defRPr b="1" sz="1800">
-                          <a:solidFill>
-                            <a:srgbClr val="FFFFFF"/>
-                          </a:solidFill>
-                        </a:defRPr>
-                      </a:pPr>
-                      <a:r>
-                        <a:t>Cost (INR)</a:t>
-                      </a:r>
-                    </a:p>
-                  </a:txBody>
-                  <a:tcPr marL="18288" marR="18288">
-                    <a:solidFill>
-                      <a:srgbClr val="003366"/>
-                    </a:solidFill>
-                  </a:tcPr>
-                </a:tc>
-                <a:tc>
-                  <a:txBody>
-                    <a:bodyPr wrap="square"/>
-                    <a:lstStyle/>
-                    <a:p>
-                      <a:pPr algn="ctr">
-                        <a:defRPr b="1" sz="1800">
-                          <a:solidFill>
-                            <a:srgbClr val="FFFFFF"/>
-                          </a:solidFill>
-                        </a:defRPr>
-                      </a:pPr>
-                      <a:r>
-                        <a:t>Brand</a:t>
-                      </a:r>
-                    </a:p>
-                  </a:txBody>
-                  <a:tcPr marL="18288" marR="18288">
-                    <a:solidFill>
-                      <a:srgbClr val="003366"/>
-                    </a:solidFill>
-                  </a:tcPr>
-                </a:tc>
-              </a:tr>
-              <a:tr h="731520">
-                <a:tc>
-                  <a:txBody>
-                    <a:bodyPr wrap="square"/>
-                    <a:lstStyle/>
-                    <a:p>
-                      <a:pPr algn="l">
-                        <a:defRPr sz="1400"/>
-                      </a:pPr>
-                      <a:r>
-                        <a:t>PROD001</a:t>
-                      </a:r>
-                    </a:p>
-                  </a:txBody>
-                  <a:tcPr marL="18288" marR="18288"/>
-                </a:tc>
-                <a:tc>
-                  <a:txBody>
-                    <a:bodyPr wrap="square"/>
-                    <a:lstStyle/>
-                    <a:p>
-                      <a:pPr algn="l">
-                        <a:defRPr sz="1400"/>
-                      </a:pPr>
-                      <a:r>
-                        <a:t>Laptop</a:t>
-                      </a:r>
-                    </a:p>
-                  </a:txBody>
-                  <a:tcPr marL="18288" marR="18288"/>
-                </a:tc>
-                <a:tc>
-                  <a:txBody>
-                    <a:bodyPr wrap="square"/>
-                    <a:lstStyle/>
-                    <a:p>
-                      <a:pPr algn="l">
-                        <a:defRPr sz="1400"/>
-                      </a:pPr>
-                      <a:r>
-                        <a:t>Electronics</a:t>
-                      </a:r>
-                    </a:p>
-                  </a:txBody>
-                  <a:tcPr marL="18288" marR="18288"/>
-                </a:tc>
-                <a:tc>
-                  <a:txBody>
-                    <a:bodyPr wrap="square"/>
-                    <a:lstStyle/>
-                    <a:p>
-                      <a:pPr algn="l">
-                        <a:defRPr sz="1400"/>
-                      </a:pPr>
-                      <a:r>
-                        <a:t>65000</a:t>
-                      </a:r>
-                    </a:p>
-                  </a:txBody>
-                  <a:tcPr marL="18288" marR="18288"/>
-                </a:tc>
-                <a:tc>
-                  <a:txBody>
-                    <a:bodyPr wrap="square"/>
-                    <a:lstStyle/>
-                    <a:p>
-                      <a:pPr algn="l">
-                        <a:defRPr sz="1400"/>
-                      </a:pPr>
-                      <a:r>
-                        <a:t>52000</a:t>
-                      </a:r>
-                    </a:p>
-                  </a:txBody>
-                  <a:tcPr marL="18288" marR="18288"/>
-                </a:tc>
-                <a:tc>
-                  <a:txBody>
-                    <a:bodyPr wrap="square"/>
-                    <a:lstStyle/>
-                    <a:p>
-                      <a:pPr algn="l">
-                        <a:defRPr sz="1400"/>
-                      </a:pPr>
-                      <a:r>
-                        <a:t>TechPro</a:t>
-                      </a:r>
-                    </a:p>
-                  </a:txBody>
-                  <a:tcPr marL="18288" marR="18288"/>
-                </a:tc>
-              </a:tr>
-              <a:tr h="731520">
-                <a:tc>
-                  <a:txBody>
-                    <a:bodyPr wrap="square"/>
-                    <a:lstStyle/>
-                    <a:p>
-                      <a:pPr algn="l">
-                        <a:defRPr sz="1400"/>
-                      </a:pPr>
-                      <a:r>
-                        <a:t>PROD002</a:t>
-                      </a:r>
-                    </a:p>
-                  </a:txBody>
-                  <a:tcPr marL="18288" marR="18288"/>
-                </a:tc>
-                <a:tc>
-                  <a:txBody>
-                    <a:bodyPr wrap="square"/>
-                    <a:lstStyle/>
-                    <a:p>
-                      <a:pPr algn="l">
-                        <a:defRPr sz="1400"/>
-                      </a:pPr>
-                      <a:r>
-                        <a:t>Smartphone</a:t>
-                      </a:r>
-                    </a:p>
-                  </a:txBody>
-                  <a:tcPr marL="18288" marR="18288"/>
-                </a:tc>
-                <a:tc>
-                  <a:txBody>
-                    <a:bodyPr wrap="square"/>
-                    <a:lstStyle/>
-                    <a:p>
-                      <a:pPr algn="l">
-                        <a:defRPr sz="1400"/>
-                      </a:pPr>
-                      <a:r>
-                        <a:t>Electronics</a:t>
-                      </a:r>
-                    </a:p>
-                  </a:txBody>
-                  <a:tcPr marL="18288" marR="18288"/>
-                </a:tc>
-                <a:tc>
-                  <a:txBody>
-                    <a:bodyPr wrap="square"/>
-                    <a:lstStyle/>
-                    <a:p>
-                      <a:pPr algn="l">
-                        <a:defRPr sz="1400"/>
-                      </a:pPr>
-                      <a:r>
-                        <a:t>32000</a:t>
-                      </a:r>
-                    </a:p>
-                  </a:txBody>
-                  <a:tcPr marL="18288" marR="18288"/>
-                </a:tc>
-                <a:tc>
-                  <a:txBody>
-                    <a:bodyPr wrap="square"/>
-                    <a:lstStyle/>
-                    <a:p>
-                      <a:pPr algn="l">
-                        <a:defRPr sz="1400"/>
-                      </a:pPr>
-                      <a:r>
-                        <a:t>25000</a:t>
-                      </a:r>
-                    </a:p>
-                  </a:txBody>
-                  <a:tcPr marL="18288" marR="18288"/>
-                </a:tc>
-                <a:tc>
-                  <a:txBody>
-                    <a:bodyPr wrap="square"/>
-                    <a:lstStyle/>
-                    <a:p>
-                      <a:pPr algn="l">
-                        <a:defRPr sz="1400"/>
-                      </a:pPr>
-                      <a:r>
-                        <a:t>SmartX</a:t>
-                      </a:r>
-                    </a:p>
-                  </a:txBody>
-                  <a:tcPr marL="18288" marR="18288"/>
-                </a:tc>
-              </a:tr>
-              <a:tr h="731520">
-                <a:tc>
-                  <a:txBody>
-                    <a:bodyPr wrap="square"/>
-                    <a:lstStyle/>
-                    <a:p>
-                      <a:pPr algn="l">
-                        <a:defRPr sz="1400"/>
-                      </a:pPr>
-                      <a:r>
-                        <a:t>PROD003</a:t>
-                      </a:r>
-                    </a:p>
-                  </a:txBody>
-                  <a:tcPr marL="18288" marR="18288"/>
-                </a:tc>
-                <a:tc>
-                  <a:txBody>
-                    <a:bodyPr wrap="square"/>
-                    <a:lstStyle/>
-                    <a:p>
-                      <a:pPr algn="l">
-                        <a:defRPr sz="1400"/>
-                      </a:pPr>
-                      <a:r>
-                        <a:t>Wireless Earbuds</a:t>
-                      </a:r>
-                    </a:p>
-                  </a:txBody>
-                  <a:tcPr marL="18288" marR="18288"/>
-                </a:tc>
-                <a:tc>
-                  <a:txBody>
-                    <a:bodyPr wrap="square"/>
-                    <a:lstStyle/>
-                    <a:p>
-                      <a:pPr algn="l">
-                        <a:defRPr sz="1400"/>
-                      </a:pPr>
-                      <a:r>
-                        <a:t>Accessories</a:t>
-                      </a:r>
-                    </a:p>
-                  </a:txBody>
-                  <a:tcPr marL="18288" marR="18288"/>
-                </a:tc>
-                <a:tc>
-                  <a:txBody>
-                    <a:bodyPr wrap="square"/>
-                    <a:lstStyle/>
-                    <a:p>
-                      <a:pPr algn="l">
-                        <a:defRPr sz="1400"/>
-                      </a:pPr>
-                      <a:r>
-                        <a:t>4500</a:t>
-                      </a:r>
-                    </a:p>
-                  </a:txBody>
-                  <a:tcPr marL="18288" marR="18288"/>
-                </a:tc>
-                <a:tc>
-                  <a:txBody>
-                    <a:bodyPr wrap="square"/>
-                    <a:lstStyle/>
-                    <a:p>
-                      <a:pPr algn="l">
-                        <a:defRPr sz="1400"/>
-                      </a:pPr>
-                      <a:r>
-                        <a:t>3000</a:t>
-                      </a:r>
-                    </a:p>
-                  </a:txBody>
-                  <a:tcPr marL="18288" marR="18288"/>
-                </a:tc>
-                <a:tc>
-                  <a:txBody>
-                    <a:bodyPr wrap="square"/>
-                    <a:lstStyle/>
-                    <a:p>
-                      <a:pPr algn="l">
-                        <a:defRPr sz="1400"/>
-                      </a:pPr>
-                      <a:r>
-                        <a:t>SoundMax</a:t>
-                      </a:r>
-                    </a:p>
-                  </a:txBody>
-                  <a:tcPr marL="18288" marR="18288"/>
-                </a:tc>
-              </a:tr>
-            </a:tbl>
-          </a:graphicData>
-        </a:graphic>
-      </p:graphicFrame>
-      <p:sp>
-        <p:nvSpPr>
-          <p:cNvPr id="4" name="TextBox 3"/>
-          <p:cNvSpPr txBox="1"/>
-          <p:nvPr/>
-        </p:nvSpPr>
-        <p:spPr>
-          <a:xfrm>
-            <a:off x="914400" y="5943600"/>
-            <a:ext cx="7315200" cy="1097280"/>
-          </a:xfrm>
-          <a:prstGeom prst="rect">
-            <a:avLst/>
-          </a:prstGeom>
-          <a:noFill/>
-        </p:spPr>
-        <p:txBody>
-          <a:bodyPr wrap="square">
-            <a:spAutoFit/>
-          </a:bodyPr>
-          <a:lstStyle/>
-          <a:p>
-            <a:pPr algn="l">
-              <a:defRPr sz="1100"/>
-            </a:pPr>
-            <a:r>
-              <a:t>The product details show a range of electronics and accessories, with varying price points and profit margins. This information is essential for inventory management and pricing strategies. High-margin products like the laptop can be a focus for promotional activities.</a:t>
-            </a:r>
-          </a:p>
-        </p:txBody>
-      </p:sp>
-      <p:pic>
-        <p:nvPicPr>
-          <p:cNvPr id="5" name="Picture 4" descr="logo.png"/>
-          <p:cNvPicPr>
-            <a:picLocks noChangeAspect="1"/>
-          </p:cNvPicPr>
-          <p:nvPr/>
-        </p:nvPicPr>
-        <p:blipFill>
-          <a:blip r:embed="rId2"/>
-          <a:stretch>
-            <a:fillRect/>
-          </a:stretch>
-        </p:blipFill>
-        <p:spPr>
-          <a:xfrm>
-            <a:off x="182880" y="182880"/>
-            <a:ext cx="1865376" cy="286335"/>
-          </a:xfrm>
-          <a:prstGeom prst="rect">
-            <a:avLst/>
-          </a:prstGeom>
-        </p:spPr>
-      </p:pic>
-      <p:sp>
-        <p:nvSpPr>
-          <p:cNvPr id="6" name="TextBox 5"/>
-          <p:cNvSpPr txBox="1"/>
-          <p:nvPr/>
-        </p:nvSpPr>
-        <p:spPr>
-          <a:xfrm>
-            <a:off x="8229600" y="6492240"/>
-            <a:ext cx="731520" cy="365760"/>
-          </a:xfrm>
-          <a:prstGeom prst="rect">
-            <a:avLst/>
-          </a:prstGeom>
-          <a:noFill/>
-        </p:spPr>
-        <p:txBody>
-          <a:bodyPr wrap="none">
-            <a:spAutoFit/>
-          </a:bodyPr>
-          <a:lstStyle/>
-          <a:p>
-            <a:pPr algn="r">
+              <a:t>- McKinsey's report highlights 13 frontier technology trends</a:t>
+            </a:r>
+          </a:p>
+          <a:p>
+            <a:pPr>
+              <a:spcAft>
+                <a:spcPts val="1200"/>
+              </a:spcAft>
               <a:defRPr sz="1800"/>
             </a:pPr>
             <a:r>
-              <a:t>4</a:t>
-            </a:r>
-          </a:p>
-        </p:txBody>
-      </p:sp>
-    </p:spTree>
-  </p:cSld>
-  <p:clrMapOvr>
-    <a:masterClrMapping/>
-  </p:clrMapOvr>
-</p:sld>
-</file>
-
-<file path=ppt/slides/slide5.xml><?xml version="1.0" encoding="utf-8"?>
-<p:sld xmlns:a="http://schemas.openxmlformats.org/drawingml/2006/main" xmlns:p="http://schemas.openxmlformats.org/presentationml/2006/main" xmlns:r="http://schemas.openxmlformats.org/officeDocument/2006/relationships">
-  <p:cSld>
-    <p:spTree>
-      <p:nvGrpSpPr>
-        <p:cNvPr id="1" name=""/>
-        <p:cNvGrpSpPr/>
-        <p:nvPr/>
-      </p:nvGrpSpPr>
-      <p:grpSpPr/>
-      <p:sp>
-        <p:nvSpPr>
-          <p:cNvPr id="2" name="Title 1"/>
-          <p:cNvSpPr>
-            <a:spLocks noGrp="1"/>
-          </p:cNvSpPr>
-          <p:nvPr>
-            <p:ph type="title"/>
-          </p:nvPr>
-        </p:nvSpPr>
-        <p:spPr/>
-        <p:txBody>
-          <a:bodyPr/>
-          <a:lstStyle/>
-          <a:p>
-            <a:r>
-              <a:t>Order Summary</a:t>
-            </a:r>
-          </a:p>
-        </p:txBody>
-      </p:sp>
-      <p:graphicFrame>
-        <p:nvGraphicFramePr>
-          <p:cNvPr id="3" name="Table 2"/>
-          <p:cNvGraphicFramePr>
-            <a:graphicFrameLocks noGrp="1"/>
-          </p:cNvGraphicFramePr>
-          <p:nvPr/>
-        </p:nvGraphicFramePr>
-        <p:xfrm>
-          <a:off x="1097280" y="1828800"/>
-          <a:ext cx="7315200" cy="2926080"/>
-        </p:xfrm>
-        <a:graphic>
-          <a:graphicData uri="http://schemas.openxmlformats.org/drawingml/2006/table">
-            <a:tbl>
-              <a:tblPr firstRow="1" bandRow="1">
-                <a:tableStyleId>{5C22544A-7EE6-4342-B048-85BDC9FD1C3A}</a:tableStyleId>
-              </a:tblPr>
-              <a:tblGrid>
-                <a:gridCol w="1045028"/>
-                <a:gridCol w="1045028"/>
-                <a:gridCol w="1045028"/>
-                <a:gridCol w="1045028"/>
-                <a:gridCol w="1045028"/>
-                <a:gridCol w="1045028"/>
-                <a:gridCol w="1045032"/>
-              </a:tblGrid>
-              <a:tr h="731520">
-                <a:tc>
-                  <a:txBody>
-                    <a:bodyPr wrap="square"/>
-                    <a:lstStyle/>
-                    <a:p>
-                      <a:pPr algn="ctr">
-                        <a:defRPr b="1" sz="1800">
-                          <a:solidFill>
-                            <a:srgbClr val="FFFFFF"/>
-                          </a:solidFill>
-                        </a:defRPr>
-                      </a:pPr>
-                      <a:r>
-                        <a:t>Order ID</a:t>
-                      </a:r>
-                    </a:p>
-                  </a:txBody>
-                  <a:tcPr marL="18288" marR="18288">
-                    <a:solidFill>
-                      <a:srgbClr val="003366"/>
-                    </a:solidFill>
-                  </a:tcPr>
-                </a:tc>
-                <a:tc>
-                  <a:txBody>
-                    <a:bodyPr wrap="square"/>
-                    <a:lstStyle/>
-                    <a:p>
-                      <a:pPr algn="ctr">
-                        <a:defRPr b="1" sz="1800">
-                          <a:solidFill>
-                            <a:srgbClr val="FFFFFF"/>
-                          </a:solidFill>
-                        </a:defRPr>
-                      </a:pPr>
-                      <a:r>
-                        <a:t>Customer ID</a:t>
-                      </a:r>
-                    </a:p>
-                  </a:txBody>
-                  <a:tcPr marL="18288" marR="18288">
-                    <a:solidFill>
-                      <a:srgbClr val="003366"/>
-                    </a:solidFill>
-                  </a:tcPr>
-                </a:tc>
-                <a:tc>
-                  <a:txBody>
-                    <a:bodyPr wrap="square"/>
-                    <a:lstStyle/>
-                    <a:p>
-                      <a:pPr algn="ctr">
-                        <a:defRPr b="1" sz="1800">
-                          <a:solidFill>
-                            <a:srgbClr val="FFFFFF"/>
-                          </a:solidFill>
-                        </a:defRPr>
-                      </a:pPr>
-                      <a:r>
-                        <a:t>Order Date</a:t>
-                      </a:r>
-                    </a:p>
-                  </a:txBody>
-                  <a:tcPr marL="18288" marR="18288">
-                    <a:solidFill>
-                      <a:srgbClr val="003366"/>
-                    </a:solidFill>
-                  </a:tcPr>
-                </a:tc>
-                <a:tc>
-                  <a:txBody>
-                    <a:bodyPr wrap="square"/>
-                    <a:lstStyle/>
-                    <a:p>
-                      <a:pPr algn="ctr">
-                        <a:defRPr b="1" sz="1800">
-                          <a:solidFill>
-                            <a:srgbClr val="FFFFFF"/>
-                          </a:solidFill>
-                        </a:defRPr>
-                      </a:pPr>
-                      <a:r>
-                        <a:t>Status</a:t>
-                      </a:r>
-                    </a:p>
-                  </a:txBody>
-                  <a:tcPr marL="18288" marR="18288">
-                    <a:solidFill>
-                      <a:srgbClr val="003366"/>
-                    </a:solidFill>
-                  </a:tcPr>
-                </a:tc>
-                <a:tc>
-                  <a:txBody>
-                    <a:bodyPr wrap="square"/>
-                    <a:lstStyle/>
-                    <a:p>
-                      <a:pPr algn="ctr">
-                        <a:defRPr b="1" sz="1800">
-                          <a:solidFill>
-                            <a:srgbClr val="FFFFFF"/>
-                          </a:solidFill>
-                        </a:defRPr>
-                      </a:pPr>
-                      <a:r>
-                        <a:t>City</a:t>
-                      </a:r>
-                    </a:p>
-                  </a:txBody>
-                  <a:tcPr marL="18288" marR="18288">
-                    <a:solidFill>
-                      <a:srgbClr val="003366"/>
-                    </a:solidFill>
-                  </a:tcPr>
-                </a:tc>
-                <a:tc>
-                  <a:txBody>
-                    <a:bodyPr wrap="square"/>
-                    <a:lstStyle/>
-                    <a:p>
-                      <a:pPr algn="ctr">
-                        <a:defRPr b="1" sz="1800">
-                          <a:solidFill>
-                            <a:srgbClr val="FFFFFF"/>
-                          </a:solidFill>
-                        </a:defRPr>
-                      </a:pPr>
-                      <a:r>
-                        <a:t>Total Amount (INR)</a:t>
-                      </a:r>
-                    </a:p>
-                  </a:txBody>
-                  <a:tcPr marL="18288" marR="18288">
-                    <a:solidFill>
-                      <a:srgbClr val="003366"/>
-                    </a:solidFill>
-                  </a:tcPr>
-                </a:tc>
-                <a:tc>
-                  <a:txBody>
-                    <a:bodyPr wrap="square"/>
-                    <a:lstStyle/>
-                    <a:p>
-                      <a:pPr algn="ctr">
-                        <a:defRPr b="1" sz="1800">
-                          <a:solidFill>
-                            <a:srgbClr val="FFFFFF"/>
-                          </a:solidFill>
-                        </a:defRPr>
-                      </a:pPr>
-                      <a:r>
-                        <a:t>Payment Mode</a:t>
-                      </a:r>
-                    </a:p>
-                  </a:txBody>
-                  <a:tcPr marL="18288" marR="18288">
-                    <a:solidFill>
-                      <a:srgbClr val="003366"/>
-                    </a:solidFill>
-                  </a:tcPr>
-                </a:tc>
-              </a:tr>
-              <a:tr h="731520">
-                <a:tc>
-                  <a:txBody>
-                    <a:bodyPr wrap="square"/>
-                    <a:lstStyle/>
-                    <a:p>
-                      <a:pPr algn="l">
-                        <a:defRPr sz="1400"/>
-                      </a:pPr>
-                      <a:r>
-                        <a:t>ORD001</a:t>
-                      </a:r>
-                    </a:p>
-                  </a:txBody>
-                  <a:tcPr marL="18288" marR="18288"/>
-                </a:tc>
-                <a:tc>
-                  <a:txBody>
-                    <a:bodyPr wrap="square"/>
-                    <a:lstStyle/>
-                    <a:p>
-                      <a:pPr algn="l">
-                        <a:defRPr sz="1400"/>
-                      </a:pPr>
-                      <a:r>
-                        <a:t>CUST001</a:t>
-                      </a:r>
-                    </a:p>
-                  </a:txBody>
-                  <a:tcPr marL="18288" marR="18288"/>
-                </a:tc>
-                <a:tc>
-                  <a:txBody>
-                    <a:bodyPr wrap="square"/>
-                    <a:lstStyle/>
-                    <a:p>
-                      <a:pPr algn="l">
-                        <a:defRPr sz="1400"/>
-                      </a:pPr>
-                      <a:r>
-                        <a:t>2025-06-14</a:t>
-                      </a:r>
-                    </a:p>
-                  </a:txBody>
-                  <a:tcPr marL="18288" marR="18288"/>
-                </a:tc>
-                <a:tc>
-                  <a:txBody>
-                    <a:bodyPr wrap="square"/>
-                    <a:lstStyle/>
-                    <a:p>
-                      <a:pPr algn="l">
-                        <a:defRPr sz="1400"/>
-                      </a:pPr>
-                      <a:r>
-                        <a:t>Delivered</a:t>
-                      </a:r>
-                    </a:p>
-                  </a:txBody>
-                  <a:tcPr marL="18288" marR="18288"/>
-                </a:tc>
-                <a:tc>
-                  <a:txBody>
-                    <a:bodyPr wrap="square"/>
-                    <a:lstStyle/>
-                    <a:p>
-                      <a:pPr algn="l">
-                        <a:defRPr sz="1400"/>
-                      </a:pPr>
-                      <a:r>
-                        <a:t>Ahmedabad</a:t>
-                      </a:r>
-                    </a:p>
-                  </a:txBody>
-                  <a:tcPr marL="18288" marR="18288"/>
-                </a:tc>
-                <a:tc>
-                  <a:txBody>
-                    <a:bodyPr wrap="square"/>
-                    <a:lstStyle/>
-                    <a:p>
-                      <a:pPr algn="l">
-                        <a:defRPr sz="1400"/>
-                      </a:pPr>
-                      <a:r>
-                        <a:t>69500</a:t>
-                      </a:r>
-                    </a:p>
-                  </a:txBody>
-                  <a:tcPr marL="18288" marR="18288"/>
-                </a:tc>
-                <a:tc>
-                  <a:txBody>
-                    <a:bodyPr wrap="square"/>
-                    <a:lstStyle/>
-                    <a:p>
-                      <a:pPr algn="l">
-                        <a:defRPr sz="1400"/>
-                      </a:pPr>
-                      <a:r>
-                        <a:t>Credit Card</a:t>
-                      </a:r>
-                    </a:p>
-                  </a:txBody>
-                  <a:tcPr marL="18288" marR="18288"/>
-                </a:tc>
-              </a:tr>
-              <a:tr h="731520">
-                <a:tc>
-                  <a:txBody>
-                    <a:bodyPr wrap="square"/>
-                    <a:lstStyle/>
-                    <a:p>
-                      <a:pPr algn="l">
-                        <a:defRPr sz="1400"/>
-                      </a:pPr>
-                      <a:r>
-                        <a:t>ORD002</a:t>
-                      </a:r>
-                    </a:p>
-                  </a:txBody>
-                  <a:tcPr marL="18288" marR="18288"/>
-                </a:tc>
-                <a:tc>
-                  <a:txBody>
-                    <a:bodyPr wrap="square"/>
-                    <a:lstStyle/>
-                    <a:p>
-                      <a:pPr algn="l">
-                        <a:defRPr sz="1400"/>
-                      </a:pPr>
-                      <a:r>
-                        <a:t>CUST002</a:t>
-                      </a:r>
-                    </a:p>
-                  </a:txBody>
-                  <a:tcPr marL="18288" marR="18288"/>
-                </a:tc>
-                <a:tc>
-                  <a:txBody>
-                    <a:bodyPr wrap="square"/>
-                    <a:lstStyle/>
-                    <a:p>
-                      <a:pPr algn="l">
-                        <a:defRPr sz="1400"/>
-                      </a:pPr>
-                      <a:r>
-                        <a:t>2025-07-01</a:t>
-                      </a:r>
-                    </a:p>
-                  </a:txBody>
-                  <a:tcPr marL="18288" marR="18288"/>
-                </a:tc>
-                <a:tc>
-                  <a:txBody>
-                    <a:bodyPr wrap="square"/>
-                    <a:lstStyle/>
-                    <a:p>
-                      <a:pPr algn="l">
-                        <a:defRPr sz="1400"/>
-                      </a:pPr>
-                      <a:r>
-                        <a:t>Delivered</a:t>
-                      </a:r>
-                    </a:p>
-                  </a:txBody>
-                  <a:tcPr marL="18288" marR="18288"/>
-                </a:tc>
-                <a:tc>
-                  <a:txBody>
-                    <a:bodyPr wrap="square"/>
-                    <a:lstStyle/>
-                    <a:p>
-                      <a:pPr algn="l">
-                        <a:defRPr sz="1400"/>
-                      </a:pPr>
-                      <a:r>
-                        <a:t>Mumbai</a:t>
-                      </a:r>
-                    </a:p>
-                  </a:txBody>
-                  <a:tcPr marL="18288" marR="18288"/>
-                </a:tc>
-                <a:tc>
-                  <a:txBody>
-                    <a:bodyPr wrap="square"/>
-                    <a:lstStyle/>
-                    <a:p>
-                      <a:pPr algn="l">
-                        <a:defRPr sz="1400"/>
-                      </a:pPr>
-                      <a:r>
-                        <a:t>36500</a:t>
-                      </a:r>
-                    </a:p>
-                  </a:txBody>
-                  <a:tcPr marL="18288" marR="18288"/>
-                </a:tc>
-                <a:tc>
-                  <a:txBody>
-                    <a:bodyPr wrap="square"/>
-                    <a:lstStyle/>
-                    <a:p>
-                      <a:pPr algn="l">
-                        <a:defRPr sz="1400"/>
-                      </a:pPr>
-                      <a:r>
-                        <a:t>UPI</a:t>
-                      </a:r>
-                    </a:p>
-                  </a:txBody>
-                  <a:tcPr marL="18288" marR="18288"/>
-                </a:tc>
-              </a:tr>
-              <a:tr h="731520">
-                <a:tc>
-                  <a:txBody>
-                    <a:bodyPr wrap="square"/>
-                    <a:lstStyle/>
-                    <a:p>
-                      <a:pPr algn="l">
-                        <a:defRPr sz="1400"/>
-                      </a:pPr>
-                      <a:r>
-                        <a:t>ORD003</a:t>
-                      </a:r>
-                    </a:p>
-                  </a:txBody>
-                  <a:tcPr marL="18288" marR="18288"/>
-                </a:tc>
-                <a:tc>
-                  <a:txBody>
-                    <a:bodyPr wrap="square"/>
-                    <a:lstStyle/>
-                    <a:p>
-                      <a:pPr algn="l">
-                        <a:defRPr sz="1400"/>
-                      </a:pPr>
-                      <a:r>
-                        <a:t>CUST003</a:t>
-                      </a:r>
-                    </a:p>
-                  </a:txBody>
-                  <a:tcPr marL="18288" marR="18288"/>
-                </a:tc>
-                <a:tc>
-                  <a:txBody>
-                    <a:bodyPr wrap="square"/>
-                    <a:lstStyle/>
-                    <a:p>
-                      <a:pPr algn="l">
-                        <a:defRPr sz="1400"/>
-                      </a:pPr>
-                      <a:r>
-                        <a:t>2025-07-10</a:t>
-                      </a:r>
-                    </a:p>
-                  </a:txBody>
-                  <a:tcPr marL="18288" marR="18288"/>
-                </a:tc>
-                <a:tc>
-                  <a:txBody>
-                    <a:bodyPr wrap="square"/>
-                    <a:lstStyle/>
-                    <a:p>
-                      <a:pPr algn="l">
-                        <a:defRPr sz="1400"/>
-                      </a:pPr>
-                      <a:r>
-                        <a:t>Cancelled</a:t>
-                      </a:r>
-                    </a:p>
-                  </a:txBody>
-                  <a:tcPr marL="18288" marR="18288"/>
-                </a:tc>
-                <a:tc>
-                  <a:txBody>
-                    <a:bodyPr wrap="square"/>
-                    <a:lstStyle/>
-                    <a:p>
-                      <a:pPr algn="l">
-                        <a:defRPr sz="1400"/>
-                      </a:pPr>
-                      <a:r>
-                        <a:t>Delhi</a:t>
-                      </a:r>
-                    </a:p>
-                  </a:txBody>
-                  <a:tcPr marL="18288" marR="18288"/>
-                </a:tc>
-                <a:tc>
-                  <a:txBody>
-                    <a:bodyPr wrap="square"/>
-                    <a:lstStyle/>
-                    <a:p>
-                      <a:pPr algn="l">
-                        <a:defRPr sz="1400"/>
-                      </a:pPr>
-                      <a:r>
-                        <a:t>4500</a:t>
-                      </a:r>
-                    </a:p>
-                  </a:txBody>
-                  <a:tcPr marL="18288" marR="18288"/>
-                </a:tc>
-                <a:tc>
-                  <a:txBody>
-                    <a:bodyPr wrap="square"/>
-                    <a:lstStyle/>
-                    <a:p>
-                      <a:pPr algn="l">
-                        <a:defRPr sz="1400"/>
-                      </a:pPr>
-                      <a:r>
-                        <a:t>Debit Card</a:t>
-                      </a:r>
-                    </a:p>
-                  </a:txBody>
-                  <a:tcPr marL="18288" marR="18288"/>
-                </a:tc>
-              </a:tr>
-            </a:tbl>
-          </a:graphicData>
-        </a:graphic>
-      </p:graphicFrame>
-      <p:sp>
-        <p:nvSpPr>
-          <p:cNvPr id="4" name="TextBox 3"/>
-          <p:cNvSpPr txBox="1"/>
-          <p:nvPr/>
-        </p:nvSpPr>
-        <p:spPr>
-          <a:xfrm>
-            <a:off x="914400" y="5943600"/>
-            <a:ext cx="7315200" cy="1097280"/>
-          </a:xfrm>
-          <a:prstGeom prst="rect">
-            <a:avLst/>
-          </a:prstGeom>
-          <a:noFill/>
-        </p:spPr>
-        <p:txBody>
-          <a:bodyPr wrap="square">
-            <a:spAutoFit/>
-          </a:bodyPr>
-          <a:lstStyle/>
-          <a:p>
-            <a:pPr algn="l">
-              <a:defRPr sz="1100"/>
-            </a:pPr>
-            <a:r>
-              <a:t>The order summary provides insights into customer purchasing behavior and the status of orders. Successful deliveries indicate efficient logistics, while the cancelled order suggests a need to investigate customer dissatisfaction. Payment modes reflect the preferred payment methods of customers.</a:t>
-            </a:r>
-          </a:p>
-        </p:txBody>
-      </p:sp>
-      <p:pic>
-        <p:nvPicPr>
-          <p:cNvPr id="5" name="Picture 4" descr="logo.png"/>
-          <p:cNvPicPr>
-            <a:picLocks noChangeAspect="1"/>
-          </p:cNvPicPr>
-          <p:nvPr/>
-        </p:nvPicPr>
-        <p:blipFill>
-          <a:blip r:embed="rId2"/>
-          <a:stretch>
-            <a:fillRect/>
-          </a:stretch>
-        </p:blipFill>
-        <p:spPr>
-          <a:xfrm>
-            <a:off x="182880" y="182880"/>
-            <a:ext cx="1865376" cy="286335"/>
-          </a:xfrm>
-          <a:prstGeom prst="rect">
-            <a:avLst/>
-          </a:prstGeom>
-        </p:spPr>
-      </p:pic>
-      <p:sp>
-        <p:nvSpPr>
-          <p:cNvPr id="6" name="TextBox 5"/>
-          <p:cNvSpPr txBox="1"/>
-          <p:nvPr/>
-        </p:nvSpPr>
-        <p:spPr>
-          <a:xfrm>
-            <a:off x="8229600" y="6492240"/>
-            <a:ext cx="731520" cy="365760"/>
-          </a:xfrm>
-          <a:prstGeom prst="rect">
-            <a:avLst/>
-          </a:prstGeom>
-          <a:noFill/>
-        </p:spPr>
-        <p:txBody>
-          <a:bodyPr wrap="none">
-            <a:spAutoFit/>
-          </a:bodyPr>
-          <a:lstStyle/>
-          <a:p>
-            <a:pPr algn="r">
+              <a:t>- These trends have the potential to transform global business</a:t>
+            </a:r>
+          </a:p>
+          <a:p>
+            <a:pPr>
+              <a:spcAft>
+                <a:spcPts val="1200"/>
+              </a:spcAft>
               <a:defRPr sz="1800"/>
             </a:pPr>
             <a:r>
-              <a:t>5</a:t>
-            </a:r>
-          </a:p>
-        </p:txBody>
-      </p:sp>
-    </p:spTree>
-  </p:cSld>
-  <p:clrMapOvr>
-    <a:masterClrMapping/>
-  </p:clrMapOvr>
-</p:sld>
-</file>
-
-<file path=ppt/slides/slide6.xml><?xml version="1.0" encoding="utf-8"?>
-<p:sld xmlns:a="http://schemas.openxmlformats.org/drawingml/2006/main" xmlns:p="http://schemas.openxmlformats.org/presentationml/2006/main" xmlns:r="http://schemas.openxmlformats.org/officeDocument/2006/relationships">
-  <p:cSld>
-    <p:spTree>
-      <p:nvGrpSpPr>
-        <p:cNvPr id="1" name=""/>
-        <p:cNvGrpSpPr/>
-        <p:nvPr/>
-      </p:nvGrpSpPr>
-      <p:grpSpPr/>
-      <p:sp>
-        <p:nvSpPr>
-          <p:cNvPr id="2" name="Title 1"/>
-          <p:cNvSpPr>
-            <a:spLocks noGrp="1"/>
-          </p:cNvSpPr>
-          <p:nvPr>
-            <p:ph type="title"/>
-          </p:nvPr>
-        </p:nvSpPr>
-        <p:spPr/>
-        <p:txBody>
-          <a:bodyPr/>
-          <a:lstStyle/>
-          <a:p>
-            <a:r>
-              <a:t>Order Items</a:t>
-            </a:r>
-          </a:p>
-        </p:txBody>
-      </p:sp>
-      <p:graphicFrame>
-        <p:nvGraphicFramePr>
-          <p:cNvPr id="3" name="Table 2"/>
-          <p:cNvGraphicFramePr>
-            <a:graphicFrameLocks noGrp="1"/>
-          </p:cNvGraphicFramePr>
-          <p:nvPr/>
-        </p:nvGraphicFramePr>
-        <p:xfrm>
-          <a:off x="1097280" y="1828800"/>
-          <a:ext cx="7315200" cy="4389120"/>
-        </p:xfrm>
-        <a:graphic>
-          <a:graphicData uri="http://schemas.openxmlformats.org/drawingml/2006/table">
-            <a:tbl>
-              <a:tblPr firstRow="1" bandRow="1">
-                <a:tableStyleId>{5C22544A-7EE6-4342-B048-85BDC9FD1C3A}</a:tableStyleId>
-              </a:tblPr>
-              <a:tblGrid>
-                <a:gridCol w="1828800"/>
-                <a:gridCol w="1828800"/>
-                <a:gridCol w="1828800"/>
-                <a:gridCol w="1828800"/>
-              </a:tblGrid>
-              <a:tr h="731520">
-                <a:tc>
-                  <a:txBody>
-                    <a:bodyPr wrap="square"/>
-                    <a:lstStyle/>
-                    <a:p>
-                      <a:pPr algn="ctr">
-                        <a:defRPr b="1" sz="1800">
-                          <a:solidFill>
-                            <a:srgbClr val="FFFFFF"/>
-                          </a:solidFill>
-                        </a:defRPr>
-                      </a:pPr>
-                      <a:r>
-                        <a:t>Order ID</a:t>
-                      </a:r>
-                    </a:p>
-                  </a:txBody>
-                  <a:tcPr marL="18288" marR="18288">
-                    <a:solidFill>
-                      <a:srgbClr val="003366"/>
-                    </a:solidFill>
-                  </a:tcPr>
-                </a:tc>
-                <a:tc>
-                  <a:txBody>
-                    <a:bodyPr wrap="square"/>
-                    <a:lstStyle/>
-                    <a:p>
-                      <a:pPr algn="ctr">
-                        <a:defRPr b="1" sz="1800">
-                          <a:solidFill>
-                            <a:srgbClr val="FFFFFF"/>
-                          </a:solidFill>
-                        </a:defRPr>
-                      </a:pPr>
-                      <a:r>
-                        <a:t>Product ID</a:t>
-                      </a:r>
-                    </a:p>
-                  </a:txBody>
-                  <a:tcPr marL="18288" marR="18288">
-                    <a:solidFill>
-                      <a:srgbClr val="003366"/>
-                    </a:solidFill>
-                  </a:tcPr>
-                </a:tc>
-                <a:tc>
-                  <a:txBody>
-                    <a:bodyPr wrap="square"/>
-                    <a:lstStyle/>
-                    <a:p>
-                      <a:pPr algn="ctr">
-                        <a:defRPr b="1" sz="1800">
-                          <a:solidFill>
-                            <a:srgbClr val="FFFFFF"/>
-                          </a:solidFill>
-                        </a:defRPr>
-                      </a:pPr>
-                      <a:r>
-                        <a:t>Quantity</a:t>
-                      </a:r>
-                    </a:p>
-                  </a:txBody>
-                  <a:tcPr marL="18288" marR="18288">
-                    <a:solidFill>
-                      <a:srgbClr val="003366"/>
-                    </a:solidFill>
-                  </a:tcPr>
-                </a:tc>
-                <a:tc>
-                  <a:txBody>
-                    <a:bodyPr wrap="square"/>
-                    <a:lstStyle/>
-                    <a:p>
-                      <a:pPr algn="ctr">
-                        <a:defRPr b="1" sz="1800">
-                          <a:solidFill>
-                            <a:srgbClr val="FFFFFF"/>
-                          </a:solidFill>
-                        </a:defRPr>
-                      </a:pPr>
-                      <a:r>
-                        <a:t>Price (INR)</a:t>
-                      </a:r>
-                    </a:p>
-                  </a:txBody>
-                  <a:tcPr marL="18288" marR="18288">
-                    <a:solidFill>
-                      <a:srgbClr val="003366"/>
-                    </a:solidFill>
-                  </a:tcPr>
-                </a:tc>
-              </a:tr>
-              <a:tr h="731520">
-                <a:tc>
-                  <a:txBody>
-                    <a:bodyPr wrap="square"/>
-                    <a:lstStyle/>
-                    <a:p>
-                      <a:pPr algn="l">
-                        <a:defRPr sz="1400"/>
-                      </a:pPr>
-                      <a:r>
-                        <a:t>ORD001</a:t>
-                      </a:r>
-                    </a:p>
-                  </a:txBody>
-                  <a:tcPr marL="18288" marR="18288"/>
-                </a:tc>
-                <a:tc>
-                  <a:txBody>
-                    <a:bodyPr wrap="square"/>
-                    <a:lstStyle/>
-                    <a:p>
-                      <a:pPr algn="l">
-                        <a:defRPr sz="1400"/>
-                      </a:pPr>
-                      <a:r>
-                        <a:t>PROD001</a:t>
-                      </a:r>
-                    </a:p>
-                  </a:txBody>
-                  <a:tcPr marL="18288" marR="18288"/>
-                </a:tc>
-                <a:tc>
-                  <a:txBody>
-                    <a:bodyPr wrap="square"/>
-                    <a:lstStyle/>
-                    <a:p>
-                      <a:pPr algn="l">
-                        <a:defRPr sz="1400"/>
-                      </a:pPr>
-                      <a:r>
-                        <a:t>1</a:t>
-                      </a:r>
-                    </a:p>
-                  </a:txBody>
-                  <a:tcPr marL="18288" marR="18288"/>
-                </a:tc>
-                <a:tc>
-                  <a:txBody>
-                    <a:bodyPr wrap="square"/>
-                    <a:lstStyle/>
-                    <a:p>
-                      <a:pPr algn="l">
-                        <a:defRPr sz="1400"/>
-                      </a:pPr>
-                      <a:r>
-                        <a:t>65000</a:t>
-                      </a:r>
-                    </a:p>
-                  </a:txBody>
-                  <a:tcPr marL="18288" marR="18288"/>
-                </a:tc>
-              </a:tr>
-              <a:tr h="731520">
-                <a:tc>
-                  <a:txBody>
-                    <a:bodyPr wrap="square"/>
-                    <a:lstStyle/>
-                    <a:p>
-                      <a:pPr algn="l">
-                        <a:defRPr sz="1400"/>
-                      </a:pPr>
-                      <a:r>
-                        <a:t>ORD001</a:t>
-                      </a:r>
-                    </a:p>
-                  </a:txBody>
-                  <a:tcPr marL="18288" marR="18288"/>
-                </a:tc>
-                <a:tc>
-                  <a:txBody>
-                    <a:bodyPr wrap="square"/>
-                    <a:lstStyle/>
-                    <a:p>
-                      <a:pPr algn="l">
-                        <a:defRPr sz="1400"/>
-                      </a:pPr>
-                      <a:r>
-                        <a:t>PROD003</a:t>
-                      </a:r>
-                    </a:p>
-                  </a:txBody>
-                  <a:tcPr marL="18288" marR="18288"/>
-                </a:tc>
-                <a:tc>
-                  <a:txBody>
-                    <a:bodyPr wrap="square"/>
-                    <a:lstStyle/>
-                    <a:p>
-                      <a:pPr algn="l">
-                        <a:defRPr sz="1400"/>
-                      </a:pPr>
-                      <a:r>
-                        <a:t>1</a:t>
-                      </a:r>
-                    </a:p>
-                  </a:txBody>
-                  <a:tcPr marL="18288" marR="18288"/>
-                </a:tc>
-                <a:tc>
-                  <a:txBody>
-                    <a:bodyPr wrap="square"/>
-                    <a:lstStyle/>
-                    <a:p>
-                      <a:pPr algn="l">
-                        <a:defRPr sz="1400"/>
-                      </a:pPr>
-                      <a:r>
-                        <a:t>4500</a:t>
-                      </a:r>
-                    </a:p>
-                  </a:txBody>
-                  <a:tcPr marL="18288" marR="18288"/>
-                </a:tc>
-              </a:tr>
-              <a:tr h="731520">
-                <a:tc>
-                  <a:txBody>
-                    <a:bodyPr wrap="square"/>
-                    <a:lstStyle/>
-                    <a:p>
-                      <a:pPr algn="l">
-                        <a:defRPr sz="1400"/>
-                      </a:pPr>
-                      <a:r>
-                        <a:t>ORD002</a:t>
-                      </a:r>
-                    </a:p>
-                  </a:txBody>
-                  <a:tcPr marL="18288" marR="18288"/>
-                </a:tc>
-                <a:tc>
-                  <a:txBody>
-                    <a:bodyPr wrap="square"/>
-                    <a:lstStyle/>
-                    <a:p>
-                      <a:pPr algn="l">
-                        <a:defRPr sz="1400"/>
-                      </a:pPr>
-                      <a:r>
-                        <a:t>PROD002</a:t>
-                      </a:r>
-                    </a:p>
-                  </a:txBody>
-                  <a:tcPr marL="18288" marR="18288"/>
-                </a:tc>
-                <a:tc>
-                  <a:txBody>
-                    <a:bodyPr wrap="square"/>
-                    <a:lstStyle/>
-                    <a:p>
-                      <a:pPr algn="l">
-                        <a:defRPr sz="1400"/>
-                      </a:pPr>
-                      <a:r>
-                        <a:t>1</a:t>
-                      </a:r>
-                    </a:p>
-                  </a:txBody>
-                  <a:tcPr marL="18288" marR="18288"/>
-                </a:tc>
-                <a:tc>
-                  <a:txBody>
-                    <a:bodyPr wrap="square"/>
-                    <a:lstStyle/>
-                    <a:p>
-                      <a:pPr algn="l">
-                        <a:defRPr sz="1400"/>
-                      </a:pPr>
-                      <a:r>
-                        <a:t>32000</a:t>
-                      </a:r>
-                    </a:p>
-                  </a:txBody>
-                  <a:tcPr marL="18288" marR="18288"/>
-                </a:tc>
-              </a:tr>
-              <a:tr h="731520">
-                <a:tc>
-                  <a:txBody>
-                    <a:bodyPr wrap="square"/>
-                    <a:lstStyle/>
-                    <a:p>
-                      <a:pPr algn="l">
-                        <a:defRPr sz="1400"/>
-                      </a:pPr>
-                      <a:r>
-                        <a:t>ORD002</a:t>
-                      </a:r>
-                    </a:p>
-                  </a:txBody>
-                  <a:tcPr marL="18288" marR="18288"/>
-                </a:tc>
-                <a:tc>
-                  <a:txBody>
-                    <a:bodyPr wrap="square"/>
-                    <a:lstStyle/>
-                    <a:p>
-                      <a:pPr algn="l">
-                        <a:defRPr sz="1400"/>
-                      </a:pPr>
-                      <a:r>
-                        <a:t>PROD003</a:t>
-                      </a:r>
-                    </a:p>
-                  </a:txBody>
-                  <a:tcPr marL="18288" marR="18288"/>
-                </a:tc>
-                <a:tc>
-                  <a:txBody>
-                    <a:bodyPr wrap="square"/>
-                    <a:lstStyle/>
-                    <a:p>
-                      <a:pPr algn="l">
-                        <a:defRPr sz="1400"/>
-                      </a:pPr>
-                      <a:r>
-                        <a:t>1</a:t>
-                      </a:r>
-                    </a:p>
-                  </a:txBody>
-                  <a:tcPr marL="18288" marR="18288"/>
-                </a:tc>
-                <a:tc>
-                  <a:txBody>
-                    <a:bodyPr wrap="square"/>
-                    <a:lstStyle/>
-                    <a:p>
-                      <a:pPr algn="l">
-                        <a:defRPr sz="1400"/>
-                      </a:pPr>
-                      <a:r>
-                        <a:t>4500</a:t>
-                      </a:r>
-                    </a:p>
-                  </a:txBody>
-                  <a:tcPr marL="18288" marR="18288"/>
-                </a:tc>
-              </a:tr>
-              <a:tr h="731520">
-                <a:tc>
-                  <a:txBody>
-                    <a:bodyPr wrap="square"/>
-                    <a:lstStyle/>
-                    <a:p>
-                      <a:pPr algn="l">
-                        <a:defRPr sz="1400"/>
-                      </a:pPr>
-                      <a:r>
-                        <a:t>ORD003</a:t>
-                      </a:r>
-                    </a:p>
-                  </a:txBody>
-                  <a:tcPr marL="18288" marR="18288"/>
-                </a:tc>
-                <a:tc>
-                  <a:txBody>
-                    <a:bodyPr wrap="square"/>
-                    <a:lstStyle/>
-                    <a:p>
-                      <a:pPr algn="l">
-                        <a:defRPr sz="1400"/>
-                      </a:pPr>
-                      <a:r>
-                        <a:t>PROD003</a:t>
-                      </a:r>
-                    </a:p>
-                  </a:txBody>
-                  <a:tcPr marL="18288" marR="18288"/>
-                </a:tc>
-                <a:tc>
-                  <a:txBody>
-                    <a:bodyPr wrap="square"/>
-                    <a:lstStyle/>
-                    <a:p>
-                      <a:pPr algn="l">
-                        <a:defRPr sz="1400"/>
-                      </a:pPr>
-                      <a:r>
-                        <a:t>1</a:t>
-                      </a:r>
-                    </a:p>
-                  </a:txBody>
-                  <a:tcPr marL="18288" marR="18288"/>
-                </a:tc>
-                <a:tc>
-                  <a:txBody>
-                    <a:bodyPr wrap="square"/>
-                    <a:lstStyle/>
-                    <a:p>
-                      <a:pPr algn="l">
-                        <a:defRPr sz="1400"/>
-                      </a:pPr>
-                      <a:r>
-                        <a:t>4500</a:t>
-                      </a:r>
-                    </a:p>
-                  </a:txBody>
-                  <a:tcPr marL="18288" marR="18288"/>
-                </a:tc>
-              </a:tr>
-            </a:tbl>
-          </a:graphicData>
-        </a:graphic>
-      </p:graphicFrame>
+              <a:t>- AI is one of the key trends impacting various sectors</a:t>
+            </a:r>
+          </a:p>
+          <a:p>
+            <a:pPr>
+              <a:spcAft>
+                <a:spcPts val="1200"/>
+              </a:spcAft>
+              <a:defRPr sz="1800"/>
+            </a:pPr>
+            <a:r>
+              <a:t>- The report provides in-depth perspectives on these trends</a:t>
+            </a:r>
+          </a:p>
+        </p:txBody>
+      </p:sp>
       <p:pic>
         <p:nvPicPr>
           <p:cNvPr id="4" name="Picture 3" descr="logo.png"/>
@@ -6005,7 +3643,7 @@
               <a:defRPr sz="1800"/>
             </a:pPr>
             <a:r>
-              <a:t>6</a:t>
+              <a:t>3</a:t>
             </a:r>
           </a:p>
         </p:txBody>
@@ -6018,7 +3656,7 @@
 </p:sld>
 </file>
 
-<file path=ppt/slides/slide7.xml><?xml version="1.0" encoding="utf-8"?>
+<file path=ppt/slides/slide4.xml><?xml version="1.0" encoding="utf-8"?>
 <p:sld xmlns:a="http://schemas.openxmlformats.org/drawingml/2006/main" xmlns:p="http://schemas.openxmlformats.org/presentationml/2006/main" xmlns:r="http://schemas.openxmlformats.org/officeDocument/2006/relationships">
   <p:cSld>
     <p:spTree>
@@ -6044,509 +3682,7 @@
           <a:lstStyle/>
           <a:p>
             <a:r>
-              <a:t>Payment Summary</a:t>
-            </a:r>
-          </a:p>
-        </p:txBody>
-      </p:sp>
-      <p:graphicFrame>
-        <p:nvGraphicFramePr>
-          <p:cNvPr id="3" name="Table 2"/>
-          <p:cNvGraphicFramePr>
-            <a:graphicFrameLocks noGrp="1"/>
-          </p:cNvGraphicFramePr>
-          <p:nvPr/>
-        </p:nvGraphicFramePr>
-        <p:xfrm>
-          <a:off x="1097280" y="1828800"/>
-          <a:ext cx="7315200" cy="2926080"/>
-        </p:xfrm>
-        <a:graphic>
-          <a:graphicData uri="http://schemas.openxmlformats.org/drawingml/2006/table">
-            <a:tbl>
-              <a:tblPr firstRow="1" bandRow="1">
-                <a:tableStyleId>{5C22544A-7EE6-4342-B048-85BDC9FD1C3A}</a:tableStyleId>
-              </a:tblPr>
-              <a:tblGrid>
-                <a:gridCol w="1463040"/>
-                <a:gridCol w="1463040"/>
-                <a:gridCol w="1463040"/>
-                <a:gridCol w="1463040"/>
-                <a:gridCol w="1463040"/>
-              </a:tblGrid>
-              <a:tr h="731520">
-                <a:tc>
-                  <a:txBody>
-                    <a:bodyPr wrap="square"/>
-                    <a:lstStyle/>
-                    <a:p>
-                      <a:pPr algn="ctr">
-                        <a:defRPr b="1" sz="1800">
-                          <a:solidFill>
-                            <a:srgbClr val="FFFFFF"/>
-                          </a:solidFill>
-                        </a:defRPr>
-                      </a:pPr>
-                      <a:r>
-                        <a:t>Payment ID</a:t>
-                      </a:r>
-                    </a:p>
-                  </a:txBody>
-                  <a:tcPr marL="18288" marR="18288">
-                    <a:solidFill>
-                      <a:srgbClr val="003366"/>
-                    </a:solidFill>
-                  </a:tcPr>
-                </a:tc>
-                <a:tc>
-                  <a:txBody>
-                    <a:bodyPr wrap="square"/>
-                    <a:lstStyle/>
-                    <a:p>
-                      <a:pPr algn="ctr">
-                        <a:defRPr b="1" sz="1800">
-                          <a:solidFill>
-                            <a:srgbClr val="FFFFFF"/>
-                          </a:solidFill>
-                        </a:defRPr>
-                      </a:pPr>
-                      <a:r>
-                        <a:t>Order ID</a:t>
-                      </a:r>
-                    </a:p>
-                  </a:txBody>
-                  <a:tcPr marL="18288" marR="18288">
-                    <a:solidFill>
-                      <a:srgbClr val="003366"/>
-                    </a:solidFill>
-                  </a:tcPr>
-                </a:tc>
-                <a:tc>
-                  <a:txBody>
-                    <a:bodyPr wrap="square"/>
-                    <a:lstStyle/>
-                    <a:p>
-                      <a:pPr algn="ctr">
-                        <a:defRPr b="1" sz="1800">
-                          <a:solidFill>
-                            <a:srgbClr val="FFFFFF"/>
-                          </a:solidFill>
-                        </a:defRPr>
-                      </a:pPr>
-                      <a:r>
-                        <a:t>Payment Status</a:t>
-                      </a:r>
-                    </a:p>
-                  </a:txBody>
-                  <a:tcPr marL="18288" marR="18288">
-                    <a:solidFill>
-                      <a:srgbClr val="003366"/>
-                    </a:solidFill>
-                  </a:tcPr>
-                </a:tc>
-                <a:tc>
-                  <a:txBody>
-                    <a:bodyPr wrap="square"/>
-                    <a:lstStyle/>
-                    <a:p>
-                      <a:pPr algn="ctr">
-                        <a:defRPr b="1" sz="1800">
-                          <a:solidFill>
-                            <a:srgbClr val="FFFFFF"/>
-                          </a:solidFill>
-                        </a:defRPr>
-                      </a:pPr>
-                      <a:r>
-                        <a:t>Transaction Date</a:t>
-                      </a:r>
-                    </a:p>
-                  </a:txBody>
-                  <a:tcPr marL="18288" marR="18288">
-                    <a:solidFill>
-                      <a:srgbClr val="003366"/>
-                    </a:solidFill>
-                  </a:tcPr>
-                </a:tc>
-                <a:tc>
-                  <a:txBody>
-                    <a:bodyPr wrap="square"/>
-                    <a:lstStyle/>
-                    <a:p>
-                      <a:pPr algn="ctr">
-                        <a:defRPr b="1" sz="1800">
-                          <a:solidFill>
-                            <a:srgbClr val="FFFFFF"/>
-                          </a:solidFill>
-                        </a:defRPr>
-                      </a:pPr>
-                      <a:r>
-                        <a:t>Amount (INR)</a:t>
-                      </a:r>
-                    </a:p>
-                  </a:txBody>
-                  <a:tcPr marL="18288" marR="18288">
-                    <a:solidFill>
-                      <a:srgbClr val="003366"/>
-                    </a:solidFill>
-                  </a:tcPr>
-                </a:tc>
-              </a:tr>
-              <a:tr h="731520">
-                <a:tc>
-                  <a:txBody>
-                    <a:bodyPr wrap="square"/>
-                    <a:lstStyle/>
-                    <a:p>
-                      <a:pPr algn="l">
-                        <a:defRPr sz="1400"/>
-                      </a:pPr>
-                      <a:r>
-                        <a:t>PAY001</a:t>
-                      </a:r>
-                    </a:p>
-                  </a:txBody>
-                  <a:tcPr marL="18288" marR="18288"/>
-                </a:tc>
-                <a:tc>
-                  <a:txBody>
-                    <a:bodyPr wrap="square"/>
-                    <a:lstStyle/>
-                    <a:p>
-                      <a:pPr algn="l">
-                        <a:defRPr sz="1400"/>
-                      </a:pPr>
-                      <a:r>
-                        <a:t>ORD001</a:t>
-                      </a:r>
-                    </a:p>
-                  </a:txBody>
-                  <a:tcPr marL="18288" marR="18288"/>
-                </a:tc>
-                <a:tc>
-                  <a:txBody>
-                    <a:bodyPr wrap="square"/>
-                    <a:lstStyle/>
-                    <a:p>
-                      <a:pPr algn="l">
-                        <a:defRPr sz="1400"/>
-                      </a:pPr>
-                      <a:r>
-                        <a:t>Success</a:t>
-                      </a:r>
-                    </a:p>
-                  </a:txBody>
-                  <a:tcPr marL="18288" marR="18288"/>
-                </a:tc>
-                <a:tc>
-                  <a:txBody>
-                    <a:bodyPr wrap="square"/>
-                    <a:lstStyle/>
-                    <a:p>
-                      <a:pPr algn="l">
-                        <a:defRPr sz="1400"/>
-                      </a:pPr>
-                      <a:r>
-                        <a:t>2025-06-14</a:t>
-                      </a:r>
-                    </a:p>
-                  </a:txBody>
-                  <a:tcPr marL="18288" marR="18288"/>
-                </a:tc>
-                <a:tc>
-                  <a:txBody>
-                    <a:bodyPr wrap="square"/>
-                    <a:lstStyle/>
-                    <a:p>
-                      <a:pPr algn="l">
-                        <a:defRPr sz="1400"/>
-                      </a:pPr>
-                      <a:r>
-                        <a:t>69500</a:t>
-                      </a:r>
-                    </a:p>
-                  </a:txBody>
-                  <a:tcPr marL="18288" marR="18288"/>
-                </a:tc>
-              </a:tr>
-              <a:tr h="731520">
-                <a:tc>
-                  <a:txBody>
-                    <a:bodyPr wrap="square"/>
-                    <a:lstStyle/>
-                    <a:p>
-                      <a:pPr algn="l">
-                        <a:defRPr sz="1400"/>
-                      </a:pPr>
-                      <a:r>
-                        <a:t>PAY002</a:t>
-                      </a:r>
-                    </a:p>
-                  </a:txBody>
-                  <a:tcPr marL="18288" marR="18288"/>
-                </a:tc>
-                <a:tc>
-                  <a:txBody>
-                    <a:bodyPr wrap="square"/>
-                    <a:lstStyle/>
-                    <a:p>
-                      <a:pPr algn="l">
-                        <a:defRPr sz="1400"/>
-                      </a:pPr>
-                      <a:r>
-                        <a:t>ORD002</a:t>
-                      </a:r>
-                    </a:p>
-                  </a:txBody>
-                  <a:tcPr marL="18288" marR="18288"/>
-                </a:tc>
-                <a:tc>
-                  <a:txBody>
-                    <a:bodyPr wrap="square"/>
-                    <a:lstStyle/>
-                    <a:p>
-                      <a:pPr algn="l">
-                        <a:defRPr sz="1400"/>
-                      </a:pPr>
-                      <a:r>
-                        <a:t>Success</a:t>
-                      </a:r>
-                    </a:p>
-                  </a:txBody>
-                  <a:tcPr marL="18288" marR="18288"/>
-                </a:tc>
-                <a:tc>
-                  <a:txBody>
-                    <a:bodyPr wrap="square"/>
-                    <a:lstStyle/>
-                    <a:p>
-                      <a:pPr algn="l">
-                        <a:defRPr sz="1400"/>
-                      </a:pPr>
-                      <a:r>
-                        <a:t>2025-07-01</a:t>
-                      </a:r>
-                    </a:p>
-                  </a:txBody>
-                  <a:tcPr marL="18288" marR="18288"/>
-                </a:tc>
-                <a:tc>
-                  <a:txBody>
-                    <a:bodyPr wrap="square"/>
-                    <a:lstStyle/>
-                    <a:p>
-                      <a:pPr algn="l">
-                        <a:defRPr sz="1400"/>
-                      </a:pPr>
-                      <a:r>
-                        <a:t>36500</a:t>
-                      </a:r>
-                    </a:p>
-                  </a:txBody>
-                  <a:tcPr marL="18288" marR="18288"/>
-                </a:tc>
-              </a:tr>
-              <a:tr h="731520">
-                <a:tc>
-                  <a:txBody>
-                    <a:bodyPr wrap="square"/>
-                    <a:lstStyle/>
-                    <a:p>
-                      <a:pPr algn="l">
-                        <a:defRPr sz="1400"/>
-                      </a:pPr>
-                      <a:r>
-                        <a:t>PAY003</a:t>
-                      </a:r>
-                    </a:p>
-                  </a:txBody>
-                  <a:tcPr marL="18288" marR="18288"/>
-                </a:tc>
-                <a:tc>
-                  <a:txBody>
-                    <a:bodyPr wrap="square"/>
-                    <a:lstStyle/>
-                    <a:p>
-                      <a:pPr algn="l">
-                        <a:defRPr sz="1400"/>
-                      </a:pPr>
-                      <a:r>
-                        <a:t>ORD003</a:t>
-                      </a:r>
-                    </a:p>
-                  </a:txBody>
-                  <a:tcPr marL="18288" marR="18288"/>
-                </a:tc>
-                <a:tc>
-                  <a:txBody>
-                    <a:bodyPr wrap="square"/>
-                    <a:lstStyle/>
-                    <a:p>
-                      <a:pPr algn="l">
-                        <a:defRPr sz="1400"/>
-                      </a:pPr>
-                      <a:r>
-                        <a:t>Refunded</a:t>
-                      </a:r>
-                    </a:p>
-                  </a:txBody>
-                  <a:tcPr marL="18288" marR="18288"/>
-                </a:tc>
-                <a:tc>
-                  <a:txBody>
-                    <a:bodyPr wrap="square"/>
-                    <a:lstStyle/>
-                    <a:p>
-                      <a:pPr algn="l">
-                        <a:defRPr sz="1400"/>
-                      </a:pPr>
-                      <a:r>
-                        <a:t>2025-07-10</a:t>
-                      </a:r>
-                    </a:p>
-                  </a:txBody>
-                  <a:tcPr marL="18288" marR="18288"/>
-                </a:tc>
-                <a:tc>
-                  <a:txBody>
-                    <a:bodyPr wrap="square"/>
-                    <a:lstStyle/>
-                    <a:p>
-                      <a:pPr algn="l">
-                        <a:defRPr sz="1400"/>
-                      </a:pPr>
-                      <a:r>
-                        <a:t>4500</a:t>
-                      </a:r>
-                    </a:p>
-                  </a:txBody>
-                  <a:tcPr marL="18288" marR="18288"/>
-                </a:tc>
-              </a:tr>
-            </a:tbl>
-          </a:graphicData>
-        </a:graphic>
-      </p:graphicFrame>
-      <p:sp>
-        <p:nvSpPr>
-          <p:cNvPr id="4" name="TextBox 3"/>
-          <p:cNvSpPr txBox="1"/>
-          <p:nvPr/>
-        </p:nvSpPr>
-        <p:spPr>
-          <a:xfrm>
-            <a:off x="914400" y="5943600"/>
-            <a:ext cx="7315200" cy="1097280"/>
-          </a:xfrm>
-          <a:prstGeom prst="rect">
-            <a:avLst/>
-          </a:prstGeom>
-          <a:noFill/>
-        </p:spPr>
-        <p:txBody>
-          <a:bodyPr wrap="square">
-            <a:spAutoFit/>
-          </a:bodyPr>
-          <a:lstStyle/>
-          <a:p>
-            <a:pPr algn="l">
-              <a:defRPr sz="1100"/>
-            </a:pPr>
-            <a:r>
-              <a:t>The payment summary shows the status of payments for each order. Successful payments indicate smooth transactions, while the refunded payment suggests a need to address customer concerns. Understanding payment trends can help in improving the checkout process.</a:t>
-            </a:r>
-          </a:p>
-        </p:txBody>
-      </p:sp>
-      <p:pic>
-        <p:nvPicPr>
-          <p:cNvPr id="5" name="Picture 4" descr="logo.png"/>
-          <p:cNvPicPr>
-            <a:picLocks noChangeAspect="1"/>
-          </p:cNvPicPr>
-          <p:nvPr/>
-        </p:nvPicPr>
-        <p:blipFill>
-          <a:blip r:embed="rId2"/>
-          <a:stretch>
-            <a:fillRect/>
-          </a:stretch>
-        </p:blipFill>
-        <p:spPr>
-          <a:xfrm>
-            <a:off x="182880" y="182880"/>
-            <a:ext cx="1865376" cy="286335"/>
-          </a:xfrm>
-          <a:prstGeom prst="rect">
-            <a:avLst/>
-          </a:prstGeom>
-        </p:spPr>
-      </p:pic>
-      <p:sp>
-        <p:nvSpPr>
-          <p:cNvPr id="6" name="TextBox 5"/>
-          <p:cNvSpPr txBox="1"/>
-          <p:nvPr/>
-        </p:nvSpPr>
-        <p:spPr>
-          <a:xfrm>
-            <a:off x="8229600" y="6492240"/>
-            <a:ext cx="731520" cy="365760"/>
-          </a:xfrm>
-          <a:prstGeom prst="rect">
-            <a:avLst/>
-          </a:prstGeom>
-          <a:noFill/>
-        </p:spPr>
-        <p:txBody>
-          <a:bodyPr wrap="none">
-            <a:spAutoFit/>
-          </a:bodyPr>
-          <a:lstStyle/>
-          <a:p>
-            <a:pPr algn="r">
-              <a:defRPr sz="1800"/>
-            </a:pPr>
-            <a:r>
-              <a:t>7</a:t>
-            </a:r>
-          </a:p>
-        </p:txBody>
-      </p:sp>
-    </p:spTree>
-  </p:cSld>
-  <p:clrMapOvr>
-    <a:masterClrMapping/>
-  </p:clrMapOvr>
-</p:sld>
-</file>
-
-<file path=ppt/slides/slide8.xml><?xml version="1.0" encoding="utf-8"?>
-<p:sld xmlns:a="http://schemas.openxmlformats.org/drawingml/2006/main" xmlns:p="http://schemas.openxmlformats.org/presentationml/2006/main" xmlns:r="http://schemas.openxmlformats.org/officeDocument/2006/relationships">
-  <p:cSld>
-    <p:spTree>
-      <p:nvGrpSpPr>
-        <p:cNvPr id="1" name=""/>
-        <p:cNvGrpSpPr/>
-        <p:nvPr/>
-      </p:nvGrpSpPr>
-      <p:grpSpPr/>
-      <p:sp>
-        <p:nvSpPr>
-          <p:cNvPr id="2" name="Title 1"/>
-          <p:cNvSpPr>
-            <a:spLocks noGrp="1"/>
-          </p:cNvSpPr>
-          <p:nvPr>
-            <p:ph type="title"/>
-          </p:nvPr>
-        </p:nvSpPr>
-        <p:spPr/>
-        <p:txBody>
-          <a:bodyPr/>
-          <a:lstStyle/>
-          <a:p>
-            <a:r>
-              <a:t>Thank You</a:t>
+              <a:t>AI and Inclusivity</a:t>
             </a:r>
           </a:p>
         </p:txBody>
@@ -6574,7 +3710,40 @@
               <a:defRPr sz="1800"/>
             </a:pPr>
             <a:r>
-              <a:t>Thank you for reviewing the Retail Analytics Dummy Data presentation. We hope this data provides valuable insights for your business strategies.</a:t>
+              <a:t>- AI is expected to promote inclusivity in the workplace</a:t>
+            </a:r>
+          </a:p>
+          <a:p>
+            <a:pPr>
+              <a:spcAft>
+                <a:spcPts val="1200"/>
+              </a:spcAft>
+              <a:defRPr sz="1800"/>
+            </a:pPr>
+            <a:r>
+              <a:t>- AI tools can help bridge gaps in accessibility</a:t>
+            </a:r>
+          </a:p>
+          <a:p>
+            <a:pPr>
+              <a:spcAft>
+                <a:spcPts val="1200"/>
+              </a:spcAft>
+              <a:defRPr sz="1800"/>
+            </a:pPr>
+            <a:r>
+              <a:t>- AI can provide personalized learning experiences</a:t>
+            </a:r>
+          </a:p>
+          <a:p>
+            <a:pPr>
+              <a:spcAft>
+                <a:spcPts val="1200"/>
+              </a:spcAft>
+              <a:defRPr sz="1800"/>
+            </a:pPr>
+            <a:r>
+              <a:t>- AI can assist in creating more equitable opportunities</a:t>
             </a:r>
           </a:p>
         </p:txBody>
@@ -6629,7 +3798,317 @@
               <a:defRPr sz="1800"/>
             </a:pPr>
             <a:r>
-              <a:t>8</a:t>
+              <a:t>4</a:t>
+            </a:r>
+          </a:p>
+        </p:txBody>
+      </p:sp>
+    </p:spTree>
+  </p:cSld>
+  <p:clrMapOvr>
+    <a:masterClrMapping/>
+  </p:clrMapOvr>
+</p:sld>
+</file>
+
+<file path=ppt/slides/slide5.xml><?xml version="1.0" encoding="utf-8"?>
+<p:sld xmlns:a="http://schemas.openxmlformats.org/drawingml/2006/main" xmlns:p="http://schemas.openxmlformats.org/presentationml/2006/main" xmlns:r="http://schemas.openxmlformats.org/officeDocument/2006/relationships">
+  <p:cSld>
+    <p:spTree>
+      <p:nvGrpSpPr>
+        <p:cNvPr id="1" name=""/>
+        <p:cNvGrpSpPr/>
+        <p:nvPr/>
+      </p:nvGrpSpPr>
+      <p:grpSpPr/>
+      <p:sp>
+        <p:nvSpPr>
+          <p:cNvPr id="2" name="Title 1"/>
+          <p:cNvSpPr>
+            <a:spLocks noGrp="1"/>
+          </p:cNvSpPr>
+          <p:nvPr>
+            <p:ph type="title"/>
+          </p:nvPr>
+        </p:nvSpPr>
+        <p:spPr/>
+        <p:txBody>
+          <a:bodyPr/>
+          <a:lstStyle/>
+          <a:p>
+            <a:r>
+              <a:t>AI in Creative Industries</a:t>
+            </a:r>
+          </a:p>
+        </p:txBody>
+      </p:sp>
+      <p:sp>
+        <p:nvSpPr>
+          <p:cNvPr id="3" name="Content Placeholder 2"/>
+          <p:cNvSpPr>
+            <a:spLocks noGrp="1"/>
+          </p:cNvSpPr>
+          <p:nvPr>
+            <p:ph idx="1"/>
+          </p:nvPr>
+        </p:nvSpPr>
+        <p:spPr/>
+        <p:txBody>
+          <a:bodyPr/>
+          <a:lstStyle/>
+          <a:p/>
+          <a:p>
+            <a:pPr>
+              <a:spcAft>
+                <a:spcPts val="1200"/>
+              </a:spcAft>
+              <a:defRPr sz="1800"/>
+            </a:pPr>
+            <a:r>
+              <a:t>- AI is transforming creative industries</a:t>
+            </a:r>
+          </a:p>
+          <a:p>
+            <a:pPr>
+              <a:spcAft>
+                <a:spcPts val="1200"/>
+              </a:spcAft>
+              <a:defRPr sz="1800"/>
+            </a:pPr>
+            <a:r>
+              <a:t>- Watercolor painting effects are a popular trend</a:t>
+            </a:r>
+          </a:p>
+          <a:p>
+            <a:pPr>
+              <a:spcAft>
+                <a:spcPts val="1200"/>
+              </a:spcAft>
+              <a:defRPr sz="1800"/>
+            </a:pPr>
+            <a:r>
+              <a:t>- AI can convert ordinary photographs into stunning artworks</a:t>
+            </a:r>
+          </a:p>
+          <a:p>
+            <a:pPr>
+              <a:spcAft>
+                <a:spcPts val="1200"/>
+              </a:spcAft>
+              <a:defRPr sz="1800"/>
+            </a:pPr>
+            <a:r>
+              <a:t>- AI is enhancing the creative process for artists and designers</a:t>
+            </a:r>
+          </a:p>
+        </p:txBody>
+      </p:sp>
+      <p:pic>
+        <p:nvPicPr>
+          <p:cNvPr id="4" name="Picture 3" descr="logo.png"/>
+          <p:cNvPicPr>
+            <a:picLocks noChangeAspect="1"/>
+          </p:cNvPicPr>
+          <p:nvPr/>
+        </p:nvPicPr>
+        <p:blipFill>
+          <a:blip r:embed="rId2"/>
+          <a:stretch>
+            <a:fillRect/>
+          </a:stretch>
+        </p:blipFill>
+        <p:spPr>
+          <a:xfrm>
+            <a:off x="182880" y="182880"/>
+            <a:ext cx="1865376" cy="286335"/>
+          </a:xfrm>
+          <a:prstGeom prst="rect">
+            <a:avLst/>
+          </a:prstGeom>
+        </p:spPr>
+      </p:pic>
+      <p:sp>
+        <p:nvSpPr>
+          <p:cNvPr id="5" name="TextBox 4"/>
+          <p:cNvSpPr txBox="1"/>
+          <p:nvPr/>
+        </p:nvSpPr>
+        <p:spPr>
+          <a:xfrm>
+            <a:off x="8229600" y="6492240"/>
+            <a:ext cx="731520" cy="365760"/>
+          </a:xfrm>
+          <a:prstGeom prst="rect">
+            <a:avLst/>
+          </a:prstGeom>
+          <a:noFill/>
+        </p:spPr>
+        <p:txBody>
+          <a:bodyPr wrap="none">
+            <a:spAutoFit/>
+          </a:bodyPr>
+          <a:lstStyle/>
+          <a:p>
+            <a:pPr algn="r">
+              <a:defRPr sz="1800"/>
+            </a:pPr>
+            <a:r>
+              <a:t>5</a:t>
+            </a:r>
+          </a:p>
+        </p:txBody>
+      </p:sp>
+    </p:spTree>
+  </p:cSld>
+  <p:clrMapOvr>
+    <a:masterClrMapping/>
+  </p:clrMapOvr>
+</p:sld>
+</file>
+
+<file path=ppt/slides/slide6.xml><?xml version="1.0" encoding="utf-8"?>
+<p:sld xmlns:a="http://schemas.openxmlformats.org/drawingml/2006/main" xmlns:p="http://schemas.openxmlformats.org/presentationml/2006/main" xmlns:r="http://schemas.openxmlformats.org/officeDocument/2006/relationships">
+  <p:cSld>
+    <p:spTree>
+      <p:nvGrpSpPr>
+        <p:cNvPr id="1" name=""/>
+        <p:cNvGrpSpPr/>
+        <p:nvPr/>
+      </p:nvGrpSpPr>
+      <p:grpSpPr/>
+      <p:sp>
+        <p:nvSpPr>
+          <p:cNvPr id="2" name="Title 1"/>
+          <p:cNvSpPr>
+            <a:spLocks noGrp="1"/>
+          </p:cNvSpPr>
+          <p:nvPr>
+            <p:ph type="title"/>
+          </p:nvPr>
+        </p:nvSpPr>
+        <p:spPr/>
+        <p:txBody>
+          <a:bodyPr/>
+          <a:lstStyle/>
+          <a:p>
+            <a:r>
+              <a:t>AI-Generated Content Opportunities</a:t>
+            </a:r>
+          </a:p>
+        </p:txBody>
+      </p:sp>
+      <p:sp>
+        <p:nvSpPr>
+          <p:cNvPr id="3" name="Content Placeholder 2"/>
+          <p:cNvSpPr>
+            <a:spLocks noGrp="1"/>
+          </p:cNvSpPr>
+          <p:nvPr>
+            <p:ph idx="1"/>
+          </p:nvPr>
+        </p:nvSpPr>
+        <p:spPr/>
+        <p:txBody>
+          <a:bodyPr/>
+          <a:lstStyle/>
+          <a:p/>
+          <a:p>
+            <a:pPr>
+              <a:spcAft>
+                <a:spcPts val="1200"/>
+              </a:spcAft>
+              <a:defRPr sz="1800"/>
+            </a:pPr>
+            <a:r>
+              <a:t>- AI is creating new opportunities in content creation</a:t>
+            </a:r>
+          </a:p>
+          <a:p>
+            <a:pPr>
+              <a:spcAft>
+                <a:spcPts val="1200"/>
+              </a:spcAft>
+              <a:defRPr sz="1800"/>
+            </a:pPr>
+            <a:r>
+              <a:t>- AI can generate content briefs using trending topics</a:t>
+            </a:r>
+          </a:p>
+          <a:p>
+            <a:pPr>
+              <a:spcAft>
+                <a:spcPts val="1200"/>
+              </a:spcAft>
+              <a:defRPr sz="1800"/>
+            </a:pPr>
+            <a:r>
+              <a:t>- AI tools like the Exploding Topics API are being used to identify trends</a:t>
+            </a:r>
+          </a:p>
+          <a:p>
+            <a:pPr>
+              <a:spcAft>
+                <a:spcPts val="1200"/>
+              </a:spcAft>
+              <a:defRPr sz="1800"/>
+            </a:pPr>
+            <a:r>
+              <a:t>- AI is making content creation more efficient and effective</a:t>
+            </a:r>
+          </a:p>
+        </p:txBody>
+      </p:sp>
+      <p:pic>
+        <p:nvPicPr>
+          <p:cNvPr id="4" name="Picture 3" descr="logo.png"/>
+          <p:cNvPicPr>
+            <a:picLocks noChangeAspect="1"/>
+          </p:cNvPicPr>
+          <p:nvPr/>
+        </p:nvPicPr>
+        <p:blipFill>
+          <a:blip r:embed="rId2"/>
+          <a:stretch>
+            <a:fillRect/>
+          </a:stretch>
+        </p:blipFill>
+        <p:spPr>
+          <a:xfrm>
+            <a:off x="182880" y="182880"/>
+            <a:ext cx="1865376" cy="286335"/>
+          </a:xfrm>
+          <a:prstGeom prst="rect">
+            <a:avLst/>
+          </a:prstGeom>
+        </p:spPr>
+      </p:pic>
+      <p:sp>
+        <p:nvSpPr>
+          <p:cNvPr id="5" name="TextBox 4"/>
+          <p:cNvSpPr txBox="1"/>
+          <p:nvPr/>
+        </p:nvSpPr>
+        <p:spPr>
+          <a:xfrm>
+            <a:off x="8229600" y="6492240"/>
+            <a:ext cx="731520" cy="365760"/>
+          </a:xfrm>
+          <a:prstGeom prst="rect">
+            <a:avLst/>
+          </a:prstGeom>
+          <a:noFill/>
+        </p:spPr>
+        <p:txBody>
+          <a:bodyPr wrap="none">
+            <a:spAutoFit/>
+          </a:bodyPr>
+          <a:lstStyle/>
+          <a:p>
+            <a:pPr algn="r">
+              <a:defRPr sz="1800"/>
+            </a:pPr>
+            <a:r>
+              <a:t>6</a:t>
             </a:r>
           </a:p>
         </p:txBody>

</xml_diff>